<commit_message>
project powerpoint drawing, project images get and post, new powerpoint project templates, updated value added notations, improved error codes, security update for images
</commit_message>
<xml_diff>
--- a/src/main/resources/templates/projectreferences/project_template_de.pptx
+++ b/src/main/resources/templates/projectreferences/project_template_de.pptx
@@ -247,7 +247,7 @@
           <a:p>
             <a:fld id="{C3440642-083C-45F1-96AE-6C40D1428CD6}" type="datetimeFigureOut">
               <a:rPr lang="en-GB" smtClean="0"/>
-              <a:t>16/04/2025</a:t>
+              <a:t>15/05/2025</a:t>
             </a:fld>
             <a:endParaRPr lang="en-GB"/>
           </a:p>
@@ -424,7 +424,7 @@
           <a:p>
             <a:fld id="{DEE2F1A5-1147-44AA-941C-401C9E3002E6}" type="datetimeFigureOut">
               <a:rPr lang="en-US" smtClean="0"/>
-              <a:t>4/16/2025</a:t>
+              <a:t>5/15/25</a:t>
             </a:fld>
             <a:endParaRPr lang="en-US"/>
           </a:p>
@@ -689,6 +689,90 @@
     </a:lvl9pPr>
   </p:notesStyle>
 </p:notesMaster>
+</file>
+
+<file path=ppt/notesSlides/notesSlide1.xml><?xml version="1.0" encoding="utf-8"?>
+<p:notes xmlns:a="http://schemas.openxmlformats.org/drawingml/2006/main" xmlns:r="http://schemas.openxmlformats.org/officeDocument/2006/relationships" xmlns:p="http://schemas.openxmlformats.org/presentationml/2006/main">
+  <p:cSld>
+    <p:spTree>
+      <p:nvGrpSpPr>
+        <p:cNvPr id="1" name=""/>
+        <p:cNvGrpSpPr/>
+        <p:nvPr/>
+      </p:nvGrpSpPr>
+      <p:grpSpPr>
+        <a:xfrm>
+          <a:off x="0" y="0"/>
+          <a:ext cx="0" cy="0"/>
+          <a:chOff x="0" y="0"/>
+          <a:chExt cx="0" cy="0"/>
+        </a:xfrm>
+      </p:grpSpPr>
+      <p:sp>
+        <p:nvSpPr>
+          <p:cNvPr id="2" name="Slide Image Placeholder 1"/>
+          <p:cNvSpPr>
+            <a:spLocks noGrp="1" noRot="1" noChangeAspect="1"/>
+          </p:cNvSpPr>
+          <p:nvPr>
+            <p:ph type="sldImg"/>
+          </p:nvPr>
+        </p:nvSpPr>
+        <p:spPr/>
+      </p:sp>
+      <p:sp>
+        <p:nvSpPr>
+          <p:cNvPr id="3" name="Notes Placeholder 2"/>
+          <p:cNvSpPr>
+            <a:spLocks noGrp="1"/>
+          </p:cNvSpPr>
+          <p:nvPr>
+            <p:ph type="body" idx="1"/>
+          </p:nvPr>
+        </p:nvSpPr>
+        <p:spPr/>
+        <p:txBody>
+          <a:bodyPr/>
+          <a:lstStyle/>
+          <a:p>
+            <a:endParaRPr lang="en-US" dirty="0"/>
+          </a:p>
+        </p:txBody>
+      </p:sp>
+      <p:sp>
+        <p:nvSpPr>
+          <p:cNvPr id="4" name="Slide Number Placeholder 3"/>
+          <p:cNvSpPr>
+            <a:spLocks noGrp="1"/>
+          </p:cNvSpPr>
+          <p:nvPr>
+            <p:ph type="sldNum" sz="quarter" idx="5"/>
+          </p:nvPr>
+        </p:nvSpPr>
+        <p:spPr/>
+        <p:txBody>
+          <a:bodyPr/>
+          <a:lstStyle/>
+          <a:p>
+            <a:fld id="{4AF3249D-E364-4AF9-8113-7FC01C784AA7}" type="slidenum">
+              <a:rPr lang="en-US" smtClean="0"/>
+              <a:t>1</a:t>
+            </a:fld>
+            <a:endParaRPr lang="en-US"/>
+          </a:p>
+        </p:txBody>
+      </p:sp>
+    </p:spTree>
+    <p:extLst>
+      <p:ext uri="{BB962C8B-B14F-4D97-AF65-F5344CB8AC3E}">
+        <p14:creationId xmlns:p14="http://schemas.microsoft.com/office/powerpoint/2010/main" val="3272386345"/>
+      </p:ext>
+    </p:extLst>
+  </p:cSld>
+  <p:clrMapOvr>
+    <a:masterClrMapping/>
+  </p:clrMapOvr>
+</p:notes>
 </file>
 
 <file path=ppt/slideLayouts/slideLayout1.xml><?xml version="1.0" encoding="utf-8"?>
@@ -3085,7 +3169,7 @@
       </p:sp>
       <p:sp>
         <p:nvSpPr>
-          <p:cNvPr id="8" name="DiamondText">
+          <p:cNvPr id="8" name="ValueAdded0">
             <a:extLst>
               <a:ext uri="{FF2B5EF4-FFF2-40B4-BE49-F238E27FC236}">
                 <a16:creationId xmlns:a16="http://schemas.microsoft.com/office/drawing/2014/main" id="{8A7F7B1D-3F29-2C31-0AAC-768FF04FB2E1}"/>
@@ -3113,7 +3197,7 @@
       </p:sp>
       <p:sp>
         <p:nvSpPr>
-          <p:cNvPr id="9" name="GraphText">
+          <p:cNvPr id="9" name="ValueAdded2">
             <a:extLst>
               <a:ext uri="{FF2B5EF4-FFF2-40B4-BE49-F238E27FC236}">
                 <a16:creationId xmlns:a16="http://schemas.microsoft.com/office/drawing/2014/main" id="{F3C4A19D-55DB-7F34-47E3-9BE3D77D4685}"/>
@@ -3141,7 +3225,7 @@
       </p:sp>
       <p:sp>
         <p:nvSpPr>
-          <p:cNvPr id="10" name="MoneyText">
+          <p:cNvPr id="10" name="ValueAdded1">
             <a:extLst>
               <a:ext uri="{FF2B5EF4-FFF2-40B4-BE49-F238E27FC236}">
                 <a16:creationId xmlns:a16="http://schemas.microsoft.com/office/drawing/2014/main" id="{7557295F-9EC4-85CD-6ECF-16945A1595BD}"/>
@@ -3167,2129 +3251,12 @@
           </a:p>
         </p:txBody>
       </p:sp>
-      <p:grpSp>
-        <p:nvGrpSpPr>
-          <p:cNvPr id="11" name="Gruppieren 10">
-            <a:extLst>
-              <a:ext uri="{FF2B5EF4-FFF2-40B4-BE49-F238E27FC236}">
-                <a16:creationId xmlns:a16="http://schemas.microsoft.com/office/drawing/2014/main" id="{4F3EF3FE-F84A-6EBA-97D3-017FF7786DA4}"/>
-              </a:ext>
-            </a:extLst>
-          </p:cNvPr>
-          <p:cNvGrpSpPr/>
-          <p:nvPr/>
-        </p:nvGrpSpPr>
-        <p:grpSpPr>
-          <a:xfrm>
-            <a:off x="693829" y="2198802"/>
-            <a:ext cx="3476940" cy="1012509"/>
-            <a:chOff x="6507861" y="2561583"/>
-            <a:chExt cx="5162131" cy="1232316"/>
-          </a:xfrm>
-        </p:grpSpPr>
-        <p:grpSp>
-          <p:nvGrpSpPr>
-            <p:cNvPr id="12" name="Gruppieren 11">
-              <a:extLst>
-                <a:ext uri="{FF2B5EF4-FFF2-40B4-BE49-F238E27FC236}">
-                  <a16:creationId xmlns:a16="http://schemas.microsoft.com/office/drawing/2014/main" id="{E52F8332-1D49-F390-243B-55952CAB015A}"/>
-                </a:ext>
-              </a:extLst>
-            </p:cNvPr>
-            <p:cNvGrpSpPr/>
-            <p:nvPr/>
-          </p:nvGrpSpPr>
-          <p:grpSpPr>
-            <a:xfrm>
-              <a:off x="6846863" y="2831951"/>
-              <a:ext cx="4823129" cy="885655"/>
-              <a:chOff x="6846863" y="2831951"/>
-              <a:chExt cx="4823129" cy="885655"/>
-            </a:xfrm>
-          </p:grpSpPr>
-          <p:grpSp>
-            <p:nvGrpSpPr>
-              <p:cNvPr id="14" name="Group 66">
-                <a:extLst>
-                  <a:ext uri="{FF2B5EF4-FFF2-40B4-BE49-F238E27FC236}">
-                    <a16:creationId xmlns:a16="http://schemas.microsoft.com/office/drawing/2014/main" id="{81E04A1A-59EC-2123-9747-1FA63B2753F5}"/>
-                  </a:ext>
-                </a:extLst>
-              </p:cNvPr>
-              <p:cNvGrpSpPr>
-                <a:grpSpLocks noChangeAspect="1"/>
-              </p:cNvGrpSpPr>
-              <p:nvPr/>
-            </p:nvGrpSpPr>
-            <p:grpSpPr>
-              <a:xfrm>
-                <a:off x="6846863" y="2831951"/>
-                <a:ext cx="4333592" cy="729400"/>
-                <a:chOff x="6262914" y="2951964"/>
-                <a:chExt cx="3860801" cy="629669"/>
-              </a:xfrm>
-              <a:solidFill>
-                <a:schemeClr val="tx2">
-                  <a:lumMod val="20000"/>
-                  <a:lumOff val="80000"/>
-                </a:schemeClr>
-              </a:solidFill>
-            </p:grpSpPr>
-            <p:grpSp>
-              <p:nvGrpSpPr>
-                <p:cNvPr id="16" name="Group 71">
-                  <a:extLst>
-                    <a:ext uri="{FF2B5EF4-FFF2-40B4-BE49-F238E27FC236}">
-                      <a16:creationId xmlns:a16="http://schemas.microsoft.com/office/drawing/2014/main" id="{7FCD2BC0-4ADB-4AB3-FC3B-49E481FB137D}"/>
-                    </a:ext>
-                  </a:extLst>
-                </p:cNvPr>
-                <p:cNvGrpSpPr/>
-                <p:nvPr/>
-              </p:nvGrpSpPr>
-              <p:grpSpPr>
-                <a:xfrm>
-                  <a:off x="6262914" y="3429000"/>
-                  <a:ext cx="3860801" cy="152633"/>
-                  <a:chOff x="6262914" y="3429000"/>
-                  <a:chExt cx="3860801" cy="152633"/>
-                </a:xfrm>
-                <a:grpFill/>
-              </p:grpSpPr>
-              <p:sp>
-                <p:nvSpPr>
-                  <p:cNvPr id="32" name="Rectangle 93">
-                    <a:extLst>
-                      <a:ext uri="{FF2B5EF4-FFF2-40B4-BE49-F238E27FC236}">
-                        <a16:creationId xmlns:a16="http://schemas.microsoft.com/office/drawing/2014/main" id="{9B0F7603-3825-A416-6227-2451B821C226}"/>
-                      </a:ext>
-                    </a:extLst>
-                  </p:cNvPr>
-                  <p:cNvSpPr/>
-                  <p:nvPr/>
-                </p:nvSpPr>
-                <p:spPr>
-                  <a:xfrm>
-                    <a:off x="6262914" y="3429000"/>
-                    <a:ext cx="478972" cy="152633"/>
-                  </a:xfrm>
-                  <a:prstGeom prst="rect">
-                    <a:avLst/>
-                  </a:prstGeom>
-                  <a:grpFill/>
-                  <a:ln w="12700" cap="flat" cmpd="sng" algn="ctr">
-                    <a:solidFill>
-                      <a:schemeClr val="bg1">
-                        <a:lumMod val="75000"/>
-                      </a:schemeClr>
-                    </a:solidFill>
-                    <a:prstDash val="solid"/>
-                    <a:miter lim="800000"/>
-                  </a:ln>
-                  <a:effectLst/>
-                </p:spPr>
-                <p:txBody>
-                  <a:bodyPr rtlCol="0" anchor="ctr"/>
-                  <a:lstStyle/>
-                  <a:p>
-                    <a:pPr marL="0" marR="0" lvl="0" indent="0" algn="ctr" defTabSz="914400" eaLnBrk="1" fontAlgn="auto" latinLnBrk="0" hangingPunct="1">
-                      <a:lnSpc>
-                        <a:spcPct val="100000"/>
-                      </a:lnSpc>
-                      <a:spcBef>
-                        <a:spcPts val="0"/>
-                      </a:spcBef>
-                      <a:spcAft>
-                        <a:spcPts val="0"/>
-                      </a:spcAft>
-                      <a:buClrTx/>
-                      <a:buSzTx/>
-                      <a:buFontTx/>
-                      <a:buNone/>
-                      <a:tabLst/>
-                      <a:defRPr/>
-                    </a:pPr>
-                    <a:r>
-                      <a:rPr kumimoji="0" lang="de-DE" sz="400" b="0" i="0" u="none" strike="noStrike" kern="0" cap="none" spc="0" normalizeH="0" baseline="0">
-                        <a:ln>
-                          <a:noFill/>
-                        </a:ln>
-                        <a:solidFill>
-                          <a:schemeClr val="accent2"/>
-                        </a:solidFill>
-                        <a:effectLst/>
-                        <a:uLnTx/>
-                        <a:uFillTx/>
-                        <a:latin typeface="Montserrat Light"/>
-                        <a:ea typeface="+mn-ea"/>
-                        <a:cs typeface="Arial" panose="020B0604020202020204" pitchFamily="34" charset="0"/>
-                      </a:rPr>
-                      <a:t>Awareness</a:t>
-                    </a:r>
-                  </a:p>
-                </p:txBody>
-              </p:sp>
-              <p:sp>
-                <p:nvSpPr>
-                  <p:cNvPr id="33" name="Rectangle 94">
-                    <a:extLst>
-                      <a:ext uri="{FF2B5EF4-FFF2-40B4-BE49-F238E27FC236}">
-                        <a16:creationId xmlns:a16="http://schemas.microsoft.com/office/drawing/2014/main" id="{6519CDBD-1FF0-8AC8-4FA7-1414099360F8}"/>
-                      </a:ext>
-                    </a:extLst>
-                  </p:cNvPr>
-                  <p:cNvSpPr/>
-                  <p:nvPr/>
-                </p:nvSpPr>
-                <p:spPr>
-                  <a:xfrm>
-                    <a:off x="6746032" y="3429000"/>
-                    <a:ext cx="478972" cy="152633"/>
-                  </a:xfrm>
-                  <a:prstGeom prst="rect">
-                    <a:avLst/>
-                  </a:prstGeom>
-                  <a:grpFill/>
-                  <a:ln w="12700" cap="flat" cmpd="sng" algn="ctr">
-                    <a:solidFill>
-                      <a:schemeClr val="bg1">
-                        <a:lumMod val="75000"/>
-                      </a:schemeClr>
-                    </a:solidFill>
-                    <a:prstDash val="solid"/>
-                    <a:miter lim="800000"/>
-                  </a:ln>
-                  <a:effectLst/>
-                </p:spPr>
-                <p:txBody>
-                  <a:bodyPr rtlCol="0" anchor="ctr"/>
-                  <a:lstStyle/>
-                  <a:p>
-                    <a:pPr marL="0" marR="0" lvl="0" indent="0" algn="ctr" defTabSz="914400" eaLnBrk="1" fontAlgn="auto" latinLnBrk="0" hangingPunct="1">
-                      <a:lnSpc>
-                        <a:spcPct val="100000"/>
-                      </a:lnSpc>
-                      <a:spcBef>
-                        <a:spcPts val="0"/>
-                      </a:spcBef>
-                      <a:spcAft>
-                        <a:spcPts val="0"/>
-                      </a:spcAft>
-                      <a:buClrTx/>
-                      <a:buSzTx/>
-                      <a:buFontTx/>
-                      <a:buNone/>
-                      <a:tabLst/>
-                      <a:defRPr/>
-                    </a:pPr>
-                    <a:r>
-                      <a:rPr kumimoji="0" lang="de-DE" sz="400" b="0" i="0" u="none" strike="noStrike" kern="0" cap="none" spc="0" normalizeH="0" baseline="0">
-                        <a:ln>
-                          <a:noFill/>
-                        </a:ln>
-                        <a:solidFill>
-                          <a:schemeClr val="accent2"/>
-                        </a:solidFill>
-                        <a:effectLst/>
-                        <a:uLnTx/>
-                        <a:uFillTx/>
-                        <a:latin typeface="Montserrat Light"/>
-                        <a:ea typeface="+mn-ea"/>
-                        <a:cs typeface="Arial" panose="020B0604020202020204" pitchFamily="34" charset="0"/>
-                      </a:rPr>
-                      <a:t>Education</a:t>
-                    </a:r>
-                  </a:p>
-                </p:txBody>
-              </p:sp>
-              <p:sp>
-                <p:nvSpPr>
-                  <p:cNvPr id="34" name="Rectangle 95">
-                    <a:extLst>
-                      <a:ext uri="{FF2B5EF4-FFF2-40B4-BE49-F238E27FC236}">
-                        <a16:creationId xmlns:a16="http://schemas.microsoft.com/office/drawing/2014/main" id="{4ED592FE-DC89-CDCA-3E0F-89796EA8CE0F}"/>
-                      </a:ext>
-                    </a:extLst>
-                  </p:cNvPr>
-                  <p:cNvSpPr/>
-                  <p:nvPr/>
-                </p:nvSpPr>
-                <p:spPr>
-                  <a:xfrm>
-                    <a:off x="7229150" y="3429000"/>
-                    <a:ext cx="478972" cy="152633"/>
-                  </a:xfrm>
-                  <a:prstGeom prst="rect">
-                    <a:avLst/>
-                  </a:prstGeom>
-                  <a:grpFill/>
-                  <a:ln w="12700" cap="flat" cmpd="sng" algn="ctr">
-                    <a:solidFill>
-                      <a:schemeClr val="bg1">
-                        <a:lumMod val="75000"/>
-                      </a:schemeClr>
-                    </a:solidFill>
-                    <a:prstDash val="solid"/>
-                    <a:miter lim="800000"/>
-                  </a:ln>
-                  <a:effectLst/>
-                </p:spPr>
-                <p:txBody>
-                  <a:bodyPr lIns="36000" rtlCol="0" anchor="ctr"/>
-                  <a:lstStyle/>
-                  <a:p>
-                    <a:pPr marL="0" marR="0" lvl="0" indent="0" algn="ctr" defTabSz="914400" eaLnBrk="1" fontAlgn="auto" latinLnBrk="0" hangingPunct="1">
-                      <a:lnSpc>
-                        <a:spcPct val="100000"/>
-                      </a:lnSpc>
-                      <a:spcBef>
-                        <a:spcPts val="0"/>
-                      </a:spcBef>
-                      <a:spcAft>
-                        <a:spcPts val="0"/>
-                      </a:spcAft>
-                      <a:buClrTx/>
-                      <a:buSzTx/>
-                      <a:buFontTx/>
-                      <a:buNone/>
-                      <a:tabLst/>
-                      <a:defRPr/>
-                    </a:pPr>
-                    <a:r>
-                      <a:rPr kumimoji="0" lang="de-DE" sz="400" b="0" i="0" u="none" strike="noStrike" kern="0" cap="none" spc="0" normalizeH="0" baseline="0" err="1">
-                        <a:ln>
-                          <a:noFill/>
-                        </a:ln>
-                        <a:solidFill>
-                          <a:schemeClr val="accent2"/>
-                        </a:solidFill>
-                        <a:effectLst/>
-                        <a:uLnTx/>
-                        <a:uFillTx/>
-                        <a:latin typeface="Montserrat Light"/>
-                        <a:ea typeface="+mn-ea"/>
-                        <a:cs typeface="Arial" panose="020B0604020202020204" pitchFamily="34" charset="0"/>
-                      </a:rPr>
-                      <a:t>Consideration</a:t>
-                    </a:r>
-                    <a:endParaRPr kumimoji="0" lang="de-DE" sz="400" b="0" i="0" u="none" strike="noStrike" kern="0" cap="none" spc="0" normalizeH="0" baseline="0">
-                      <a:ln>
-                        <a:noFill/>
-                      </a:ln>
-                      <a:solidFill>
-                        <a:schemeClr val="accent2"/>
-                      </a:solidFill>
-                      <a:effectLst/>
-                      <a:uLnTx/>
-                      <a:uFillTx/>
-                      <a:latin typeface="Montserrat Light"/>
-                      <a:ea typeface="+mn-ea"/>
-                      <a:cs typeface="Arial" panose="020B0604020202020204" pitchFamily="34" charset="0"/>
-                    </a:endParaRPr>
-                  </a:p>
-                </p:txBody>
-              </p:sp>
-              <p:sp>
-                <p:nvSpPr>
-                  <p:cNvPr id="35" name="Rectangle 96">
-                    <a:extLst>
-                      <a:ext uri="{FF2B5EF4-FFF2-40B4-BE49-F238E27FC236}">
-                        <a16:creationId xmlns:a16="http://schemas.microsoft.com/office/drawing/2014/main" id="{E2604AC3-F7B4-39FA-3B19-35DCAC58DE48}"/>
-                      </a:ext>
-                    </a:extLst>
-                  </p:cNvPr>
-                  <p:cNvSpPr/>
-                  <p:nvPr/>
-                </p:nvSpPr>
-                <p:spPr>
-                  <a:xfrm>
-                    <a:off x="7712268" y="3429000"/>
-                    <a:ext cx="478972" cy="152633"/>
-                  </a:xfrm>
-                  <a:prstGeom prst="rect">
-                    <a:avLst/>
-                  </a:prstGeom>
-                  <a:grpFill/>
-                  <a:ln w="12700" cap="flat" cmpd="sng" algn="ctr">
-                    <a:solidFill>
-                      <a:schemeClr val="bg1">
-                        <a:lumMod val="75000"/>
-                      </a:schemeClr>
-                    </a:solidFill>
-                    <a:prstDash val="solid"/>
-                    <a:miter lim="800000"/>
-                  </a:ln>
-                  <a:effectLst/>
-                </p:spPr>
-                <p:txBody>
-                  <a:bodyPr rtlCol="0" anchor="ctr"/>
-                  <a:lstStyle/>
-                  <a:p>
-                    <a:pPr marL="0" marR="0" lvl="0" indent="0" algn="ctr" defTabSz="914400" eaLnBrk="1" fontAlgn="auto" latinLnBrk="0" hangingPunct="1">
-                      <a:lnSpc>
-                        <a:spcPct val="100000"/>
-                      </a:lnSpc>
-                      <a:spcBef>
-                        <a:spcPts val="0"/>
-                      </a:spcBef>
-                      <a:spcAft>
-                        <a:spcPts val="0"/>
-                      </a:spcAft>
-                      <a:buClrTx/>
-                      <a:buSzTx/>
-                      <a:buFontTx/>
-                      <a:buNone/>
-                      <a:tabLst/>
-                      <a:defRPr/>
-                    </a:pPr>
-                    <a:r>
-                      <a:rPr kumimoji="0" lang="de-DE" sz="400" b="0" i="0" u="none" strike="noStrike" kern="0" cap="none" spc="0" normalizeH="0" baseline="0" err="1">
-                        <a:ln>
-                          <a:noFill/>
-                        </a:ln>
-                        <a:solidFill>
-                          <a:schemeClr val="accent2"/>
-                        </a:solidFill>
-                        <a:effectLst/>
-                        <a:uLnTx/>
-                        <a:uFillTx/>
-                        <a:latin typeface="Montserrat Light"/>
-                        <a:ea typeface="+mn-ea"/>
-                        <a:cs typeface="Arial" panose="020B0604020202020204" pitchFamily="34" charset="0"/>
-                      </a:rPr>
-                      <a:t>Purchase</a:t>
-                    </a:r>
-                    <a:endParaRPr kumimoji="0" lang="de-DE" sz="400" b="0" i="0" u="none" strike="noStrike" kern="0" cap="none" spc="0" normalizeH="0" baseline="0">
-                      <a:ln>
-                        <a:noFill/>
-                      </a:ln>
-                      <a:solidFill>
-                        <a:schemeClr val="accent2"/>
-                      </a:solidFill>
-                      <a:effectLst/>
-                      <a:uLnTx/>
-                      <a:uFillTx/>
-                      <a:latin typeface="Montserrat Light"/>
-                      <a:ea typeface="+mn-ea"/>
-                      <a:cs typeface="Arial" panose="020B0604020202020204" pitchFamily="34" charset="0"/>
-                    </a:endParaRPr>
-                  </a:p>
-                </p:txBody>
-              </p:sp>
-              <p:sp>
-                <p:nvSpPr>
-                  <p:cNvPr id="36" name="Rectangle 97">
-                    <a:extLst>
-                      <a:ext uri="{FF2B5EF4-FFF2-40B4-BE49-F238E27FC236}">
-                        <a16:creationId xmlns:a16="http://schemas.microsoft.com/office/drawing/2014/main" id="{FABC512B-D65D-CB46-0DA3-937485A02331}"/>
-                      </a:ext>
-                    </a:extLst>
-                  </p:cNvPr>
-                  <p:cNvSpPr/>
-                  <p:nvPr/>
-                </p:nvSpPr>
-                <p:spPr>
-                  <a:xfrm>
-                    <a:off x="8195386" y="3429000"/>
-                    <a:ext cx="478972" cy="152633"/>
-                  </a:xfrm>
-                  <a:prstGeom prst="rect">
-                    <a:avLst/>
-                  </a:prstGeom>
-                  <a:grpFill/>
-                  <a:ln w="12700" cap="flat" cmpd="sng" algn="ctr">
-                    <a:solidFill>
-                      <a:schemeClr val="bg1">
-                        <a:lumMod val="75000"/>
-                      </a:schemeClr>
-                    </a:solidFill>
-                    <a:prstDash val="solid"/>
-                    <a:miter lim="800000"/>
-                  </a:ln>
-                  <a:effectLst/>
-                </p:spPr>
-                <p:txBody>
-                  <a:bodyPr rtlCol="0" anchor="ctr"/>
-                  <a:lstStyle/>
-                  <a:p>
-                    <a:pPr marL="0" marR="0" lvl="0" indent="0" algn="ctr" defTabSz="914400" eaLnBrk="1" fontAlgn="auto" latinLnBrk="0" hangingPunct="1">
-                      <a:lnSpc>
-                        <a:spcPct val="100000"/>
-                      </a:lnSpc>
-                      <a:spcBef>
-                        <a:spcPts val="0"/>
-                      </a:spcBef>
-                      <a:spcAft>
-                        <a:spcPts val="0"/>
-                      </a:spcAft>
-                      <a:buClrTx/>
-                      <a:buSzTx/>
-                      <a:buFontTx/>
-                      <a:buNone/>
-                      <a:tabLst/>
-                      <a:defRPr/>
-                    </a:pPr>
-                    <a:r>
-                      <a:rPr kumimoji="0" lang="de-DE" sz="400" b="0" i="0" u="none" strike="noStrike" kern="0" cap="none" spc="0" normalizeH="0" baseline="0">
-                        <a:ln>
-                          <a:noFill/>
-                        </a:ln>
-                        <a:solidFill>
-                          <a:schemeClr val="accent2"/>
-                        </a:solidFill>
-                        <a:effectLst/>
-                        <a:uLnTx/>
-                        <a:uFillTx/>
-                        <a:latin typeface="Montserrat Light"/>
-                        <a:ea typeface="+mn-ea"/>
-                        <a:cs typeface="Arial" panose="020B0604020202020204" pitchFamily="34" charset="0"/>
-                      </a:rPr>
-                      <a:t>Adoption</a:t>
-                    </a:r>
-                  </a:p>
-                </p:txBody>
-              </p:sp>
-              <p:sp>
-                <p:nvSpPr>
-                  <p:cNvPr id="37" name="Rectangle 98">
-                    <a:extLst>
-                      <a:ext uri="{FF2B5EF4-FFF2-40B4-BE49-F238E27FC236}">
-                        <a16:creationId xmlns:a16="http://schemas.microsoft.com/office/drawing/2014/main" id="{0EAC97A0-57DA-F7CF-F5C1-E9403FADF18A}"/>
-                      </a:ext>
-                    </a:extLst>
-                  </p:cNvPr>
-                  <p:cNvSpPr/>
-                  <p:nvPr/>
-                </p:nvSpPr>
-                <p:spPr>
-                  <a:xfrm>
-                    <a:off x="8678504" y="3429000"/>
-                    <a:ext cx="478972" cy="152633"/>
-                  </a:xfrm>
-                  <a:prstGeom prst="rect">
-                    <a:avLst/>
-                  </a:prstGeom>
-                  <a:grpFill/>
-                  <a:ln w="12700" cap="flat" cmpd="sng" algn="ctr">
-                    <a:solidFill>
-                      <a:schemeClr val="bg1">
-                        <a:lumMod val="75000"/>
-                      </a:schemeClr>
-                    </a:solidFill>
-                    <a:prstDash val="solid"/>
-                    <a:miter lim="800000"/>
-                  </a:ln>
-                  <a:effectLst/>
-                </p:spPr>
-                <p:txBody>
-                  <a:bodyPr rtlCol="0" anchor="ctr"/>
-                  <a:lstStyle/>
-                  <a:p>
-                    <a:pPr marL="0" marR="0" lvl="0" indent="0" algn="ctr" defTabSz="914400" eaLnBrk="1" fontAlgn="auto" latinLnBrk="0" hangingPunct="1">
-                      <a:lnSpc>
-                        <a:spcPct val="100000"/>
-                      </a:lnSpc>
-                      <a:spcBef>
-                        <a:spcPts val="0"/>
-                      </a:spcBef>
-                      <a:spcAft>
-                        <a:spcPts val="0"/>
-                      </a:spcAft>
-                      <a:buClrTx/>
-                      <a:buSzTx/>
-                      <a:buFontTx/>
-                      <a:buNone/>
-                      <a:tabLst/>
-                      <a:defRPr/>
-                    </a:pPr>
-                    <a:r>
-                      <a:rPr kumimoji="0" lang="de-DE" sz="400" b="0" i="0" u="none" strike="noStrike" kern="0" cap="none" spc="0" normalizeH="0" baseline="0">
-                        <a:ln>
-                          <a:noFill/>
-                        </a:ln>
-                        <a:solidFill>
-                          <a:schemeClr val="accent2"/>
-                        </a:solidFill>
-                        <a:effectLst/>
-                        <a:uLnTx/>
-                        <a:uFillTx/>
-                        <a:latin typeface="Montserrat Light"/>
-                        <a:ea typeface="+mn-ea"/>
-                        <a:cs typeface="Arial" panose="020B0604020202020204" pitchFamily="34" charset="0"/>
-                      </a:rPr>
-                      <a:t>Retention</a:t>
-                    </a:r>
-                  </a:p>
-                </p:txBody>
-              </p:sp>
-              <p:sp>
-                <p:nvSpPr>
-                  <p:cNvPr id="38" name="Rectangle 99">
-                    <a:extLst>
-                      <a:ext uri="{FF2B5EF4-FFF2-40B4-BE49-F238E27FC236}">
-                        <a16:creationId xmlns:a16="http://schemas.microsoft.com/office/drawing/2014/main" id="{131DD477-2478-B8FD-B242-D30865B2C21E}"/>
-                      </a:ext>
-                    </a:extLst>
-                  </p:cNvPr>
-                  <p:cNvSpPr/>
-                  <p:nvPr/>
-                </p:nvSpPr>
-                <p:spPr>
-                  <a:xfrm>
-                    <a:off x="9161622" y="3429000"/>
-                    <a:ext cx="478972" cy="152633"/>
-                  </a:xfrm>
-                  <a:prstGeom prst="rect">
-                    <a:avLst/>
-                  </a:prstGeom>
-                  <a:grpFill/>
-                  <a:ln w="12700" cap="flat" cmpd="sng" algn="ctr">
-                    <a:solidFill>
-                      <a:schemeClr val="bg1">
-                        <a:lumMod val="75000"/>
-                      </a:schemeClr>
-                    </a:solidFill>
-                    <a:prstDash val="solid"/>
-                    <a:miter lim="800000"/>
-                  </a:ln>
-                  <a:effectLst/>
-                </p:spPr>
-                <p:txBody>
-                  <a:bodyPr rtlCol="0" anchor="ctr"/>
-                  <a:lstStyle/>
-                  <a:p>
-                    <a:pPr marL="0" marR="0" lvl="0" indent="0" algn="ctr" defTabSz="914400" eaLnBrk="1" fontAlgn="auto" latinLnBrk="0" hangingPunct="1">
-                      <a:lnSpc>
-                        <a:spcPct val="100000"/>
-                      </a:lnSpc>
-                      <a:spcBef>
-                        <a:spcPts val="0"/>
-                      </a:spcBef>
-                      <a:spcAft>
-                        <a:spcPts val="0"/>
-                      </a:spcAft>
-                      <a:buClrTx/>
-                      <a:buSzTx/>
-                      <a:buFontTx/>
-                      <a:buNone/>
-                      <a:tabLst/>
-                      <a:defRPr/>
-                    </a:pPr>
-                    <a:r>
-                      <a:rPr kumimoji="0" lang="de-DE" sz="400" b="0" i="0" u="none" strike="noStrike" kern="0" cap="none" spc="0" normalizeH="0" baseline="0">
-                        <a:ln>
-                          <a:noFill/>
-                        </a:ln>
-                        <a:solidFill>
-                          <a:schemeClr val="accent2"/>
-                        </a:solidFill>
-                        <a:effectLst/>
-                        <a:uLnTx/>
-                        <a:uFillTx/>
-                        <a:latin typeface="Montserrat Light"/>
-                        <a:ea typeface="+mn-ea"/>
-                        <a:cs typeface="Arial" panose="020B0604020202020204" pitchFamily="34" charset="0"/>
-                      </a:rPr>
-                      <a:t>Expansion</a:t>
-                    </a:r>
-                  </a:p>
-                </p:txBody>
-              </p:sp>
-              <p:sp>
-                <p:nvSpPr>
-                  <p:cNvPr id="39" name="Rectangle 102">
-                    <a:extLst>
-                      <a:ext uri="{FF2B5EF4-FFF2-40B4-BE49-F238E27FC236}">
-                        <a16:creationId xmlns:a16="http://schemas.microsoft.com/office/drawing/2014/main" id="{E48D47E8-D167-CE8B-B0AE-4AFFF28191C2}"/>
-                      </a:ext>
-                    </a:extLst>
-                  </p:cNvPr>
-                  <p:cNvSpPr/>
-                  <p:nvPr/>
-                </p:nvSpPr>
-                <p:spPr>
-                  <a:xfrm>
-                    <a:off x="9644743" y="3429000"/>
-                    <a:ext cx="478972" cy="152633"/>
-                  </a:xfrm>
-                  <a:prstGeom prst="rect">
-                    <a:avLst/>
-                  </a:prstGeom>
-                  <a:grpFill/>
-                  <a:ln w="12700" cap="flat" cmpd="sng" algn="ctr">
-                    <a:solidFill>
-                      <a:schemeClr val="bg1">
-                        <a:lumMod val="75000"/>
-                      </a:schemeClr>
-                    </a:solidFill>
-                    <a:prstDash val="solid"/>
-                    <a:miter lim="800000"/>
-                  </a:ln>
-                  <a:effectLst/>
-                </p:spPr>
-                <p:txBody>
-                  <a:bodyPr rtlCol="0" anchor="ctr"/>
-                  <a:lstStyle/>
-                  <a:p>
-                    <a:pPr marL="0" marR="0" lvl="0" indent="0" algn="ctr" defTabSz="914400" eaLnBrk="1" fontAlgn="auto" latinLnBrk="0" hangingPunct="1">
-                      <a:lnSpc>
-                        <a:spcPct val="100000"/>
-                      </a:lnSpc>
-                      <a:spcBef>
-                        <a:spcPts val="0"/>
-                      </a:spcBef>
-                      <a:spcAft>
-                        <a:spcPts val="0"/>
-                      </a:spcAft>
-                      <a:buClrTx/>
-                      <a:buSzTx/>
-                      <a:buFontTx/>
-                      <a:buNone/>
-                      <a:tabLst/>
-                      <a:defRPr/>
-                    </a:pPr>
-                    <a:r>
-                      <a:rPr kumimoji="0" lang="de-DE" sz="400" b="0" i="0" u="none" strike="noStrike" kern="0" cap="none" spc="0" normalizeH="0" baseline="0" err="1">
-                        <a:ln>
-                          <a:noFill/>
-                        </a:ln>
-                        <a:solidFill>
-                          <a:schemeClr val="accent2"/>
-                        </a:solidFill>
-                        <a:effectLst/>
-                        <a:uLnTx/>
-                        <a:uFillTx/>
-                        <a:latin typeface="Montserrat Light"/>
-                        <a:ea typeface="+mn-ea"/>
-                        <a:cs typeface="Arial" panose="020B0604020202020204" pitchFamily="34" charset="0"/>
-                      </a:rPr>
-                      <a:t>Advocacy</a:t>
-                    </a:r>
-                    <a:endParaRPr kumimoji="0" lang="de-DE" sz="400" b="0" i="0" u="none" strike="noStrike" kern="0" cap="none" spc="0" normalizeH="0" baseline="0">
-                      <a:ln>
-                        <a:noFill/>
-                      </a:ln>
-                      <a:solidFill>
-                        <a:schemeClr val="accent2"/>
-                      </a:solidFill>
-                      <a:effectLst/>
-                      <a:uLnTx/>
-                      <a:uFillTx/>
-                      <a:latin typeface="Montserrat Light"/>
-                      <a:ea typeface="+mn-ea"/>
-                      <a:cs typeface="Arial" panose="020B0604020202020204" pitchFamily="34" charset="0"/>
-                    </a:endParaRPr>
-                  </a:p>
-                </p:txBody>
-              </p:sp>
-            </p:grpSp>
-            <p:sp>
-              <p:nvSpPr>
-                <p:cNvPr id="17" name="Oval 36">
-                  <a:extLst>
-                    <a:ext uri="{FF2B5EF4-FFF2-40B4-BE49-F238E27FC236}">
-                      <a16:creationId xmlns:a16="http://schemas.microsoft.com/office/drawing/2014/main" id="{694571FB-F77F-E055-8279-BF0279B4E71B}"/>
-                    </a:ext>
-                  </a:extLst>
-                </p:cNvPr>
-                <p:cNvSpPr/>
-                <p:nvPr/>
-              </p:nvSpPr>
-              <p:spPr>
-                <a:xfrm>
-                  <a:off x="6354935" y="3149836"/>
-                  <a:ext cx="72000" cy="72000"/>
-                </a:xfrm>
-                <a:prstGeom prst="ellipse">
-                  <a:avLst/>
-                </a:prstGeom>
-                <a:grpFill/>
-                <a:ln w="12700" cap="flat" cmpd="sng" algn="ctr">
-                  <a:solidFill>
-                    <a:schemeClr val="bg1">
-                      <a:lumMod val="75000"/>
-                    </a:schemeClr>
-                  </a:solidFill>
-                  <a:prstDash val="solid"/>
-                  <a:miter lim="800000"/>
-                </a:ln>
-                <a:effectLst/>
-              </p:spPr>
-              <p:txBody>
-                <a:bodyPr rtlCol="0" anchor="ctr"/>
-                <a:lstStyle/>
-                <a:p>
-                  <a:pPr marL="0" marR="0" lvl="0" indent="0" algn="ctr" defTabSz="914400" eaLnBrk="1" fontAlgn="auto" latinLnBrk="0" hangingPunct="1">
-                    <a:lnSpc>
-                      <a:spcPct val="100000"/>
-                    </a:lnSpc>
-                    <a:spcBef>
-                      <a:spcPts val="0"/>
-                    </a:spcBef>
-                    <a:spcAft>
-                      <a:spcPts val="0"/>
-                    </a:spcAft>
-                    <a:buClrTx/>
-                    <a:buSzTx/>
-                    <a:buFontTx/>
-                    <a:buNone/>
-                    <a:tabLst/>
-                    <a:defRPr/>
-                  </a:pPr>
-                  <a:r>
-                    <a:rPr kumimoji="0" lang="de-DE" sz="600" b="0" i="0" u="none" strike="noStrike" kern="0" cap="none" spc="0" normalizeH="0" baseline="0">
-                      <a:ln>
-                        <a:noFill/>
-                      </a:ln>
-                      <a:solidFill>
-                        <a:schemeClr val="accent2"/>
-                      </a:solidFill>
-                      <a:effectLst/>
-                      <a:uLnTx/>
-                      <a:uFillTx/>
-                      <a:latin typeface="Montserrat Light"/>
-                      <a:ea typeface="+mn-ea"/>
-                      <a:cs typeface="Cordia New"/>
-                    </a:rPr>
-                    <a:t>3</a:t>
-                  </a:r>
-                </a:p>
-              </p:txBody>
-            </p:sp>
-            <p:sp>
-              <p:nvSpPr>
-                <p:cNvPr id="18" name="Oval 39">
-                  <a:extLst>
-                    <a:ext uri="{FF2B5EF4-FFF2-40B4-BE49-F238E27FC236}">
-                      <a16:creationId xmlns:a16="http://schemas.microsoft.com/office/drawing/2014/main" id="{5444D042-9E27-21A7-56A2-0CDE094BDB7D}"/>
-                    </a:ext>
-                  </a:extLst>
-                </p:cNvPr>
-                <p:cNvSpPr/>
-                <p:nvPr/>
-              </p:nvSpPr>
-              <p:spPr>
-                <a:xfrm>
-                  <a:off x="6499916" y="3230393"/>
-                  <a:ext cx="72000" cy="72000"/>
-                </a:xfrm>
-                <a:prstGeom prst="ellipse">
-                  <a:avLst/>
-                </a:prstGeom>
-                <a:grpFill/>
-                <a:ln w="12700" cap="flat" cmpd="sng" algn="ctr">
-                  <a:solidFill>
-                    <a:schemeClr val="bg1">
-                      <a:lumMod val="75000"/>
-                    </a:schemeClr>
-                  </a:solidFill>
-                  <a:prstDash val="solid"/>
-                  <a:miter lim="800000"/>
-                </a:ln>
-                <a:effectLst/>
-              </p:spPr>
-              <p:txBody>
-                <a:bodyPr rtlCol="0" anchor="ctr"/>
-                <a:lstStyle/>
-                <a:p>
-                  <a:pPr marL="0" marR="0" lvl="0" indent="0" algn="ctr" defTabSz="914400" eaLnBrk="1" fontAlgn="auto" latinLnBrk="0" hangingPunct="1">
-                    <a:lnSpc>
-                      <a:spcPct val="100000"/>
-                    </a:lnSpc>
-                    <a:spcBef>
-                      <a:spcPts val="0"/>
-                    </a:spcBef>
-                    <a:spcAft>
-                      <a:spcPts val="0"/>
-                    </a:spcAft>
-                    <a:buClrTx/>
-                    <a:buSzTx/>
-                    <a:buFontTx/>
-                    <a:buNone/>
-                    <a:tabLst/>
-                    <a:defRPr/>
-                  </a:pPr>
-                  <a:r>
-                    <a:rPr kumimoji="0" lang="de-DE" sz="600" b="0" i="0" u="none" strike="noStrike" kern="0" cap="none" spc="0" normalizeH="0" baseline="0">
-                      <a:ln>
-                        <a:noFill/>
-                      </a:ln>
-                      <a:solidFill>
-                        <a:schemeClr val="accent2"/>
-                      </a:solidFill>
-                      <a:effectLst/>
-                      <a:uLnTx/>
-                      <a:uFillTx/>
-                      <a:latin typeface="Montserrat Light"/>
-                      <a:ea typeface="+mn-ea"/>
-                      <a:cs typeface="Cordia New"/>
-                    </a:rPr>
-                    <a:t>6</a:t>
-                  </a:r>
-                </a:p>
-              </p:txBody>
-            </p:sp>
-            <p:sp>
-              <p:nvSpPr>
-                <p:cNvPr id="19" name="Oval 41">
-                  <a:extLst>
-                    <a:ext uri="{FF2B5EF4-FFF2-40B4-BE49-F238E27FC236}">
-                      <a16:creationId xmlns:a16="http://schemas.microsoft.com/office/drawing/2014/main" id="{FEEBC8F7-23C1-7860-2244-5EDAF4C987FD}"/>
-                    </a:ext>
-                  </a:extLst>
-                </p:cNvPr>
-                <p:cNvSpPr/>
-                <p:nvPr/>
-              </p:nvSpPr>
-              <p:spPr>
-                <a:xfrm>
-                  <a:off x="6581500" y="3079121"/>
-                  <a:ext cx="108000" cy="108000"/>
-                </a:xfrm>
-                <a:prstGeom prst="ellipse">
-                  <a:avLst/>
-                </a:prstGeom>
-                <a:grpFill/>
-                <a:ln w="12700" cap="flat" cmpd="sng" algn="ctr">
-                  <a:solidFill>
-                    <a:schemeClr val="bg1">
-                      <a:lumMod val="75000"/>
-                    </a:schemeClr>
-                  </a:solidFill>
-                  <a:prstDash val="solid"/>
-                  <a:miter lim="800000"/>
-                </a:ln>
-                <a:effectLst/>
-              </p:spPr>
-              <p:txBody>
-                <a:bodyPr rtlCol="0" anchor="ctr"/>
-                <a:lstStyle/>
-                <a:p>
-                  <a:pPr marL="0" marR="0" lvl="0" indent="0" algn="ctr" defTabSz="914400" eaLnBrk="1" fontAlgn="auto" latinLnBrk="0" hangingPunct="1">
-                    <a:lnSpc>
-                      <a:spcPct val="100000"/>
-                    </a:lnSpc>
-                    <a:spcBef>
-                      <a:spcPts val="0"/>
-                    </a:spcBef>
-                    <a:spcAft>
-                      <a:spcPts val="0"/>
-                    </a:spcAft>
-                    <a:buClrTx/>
-                    <a:buSzTx/>
-                    <a:buFontTx/>
-                    <a:buNone/>
-                    <a:tabLst/>
-                    <a:defRPr/>
-                  </a:pPr>
-                  <a:r>
-                    <a:rPr kumimoji="0" lang="de-DE" sz="600" b="0" i="0" u="none" strike="noStrike" kern="0" cap="none" spc="0" normalizeH="0" baseline="0">
-                      <a:ln>
-                        <a:noFill/>
-                      </a:ln>
-                      <a:solidFill>
-                        <a:schemeClr val="accent2"/>
-                      </a:solidFill>
-                      <a:effectLst/>
-                      <a:uLnTx/>
-                      <a:uFillTx/>
-                      <a:latin typeface="Montserrat Light"/>
-                      <a:ea typeface="+mn-ea"/>
-                      <a:cs typeface="Cordia New"/>
-                    </a:rPr>
-                    <a:t>1</a:t>
-                  </a:r>
-                </a:p>
-              </p:txBody>
-            </p:sp>
-            <p:sp>
-              <p:nvSpPr>
-                <p:cNvPr id="20" name="Oval 42">
-                  <a:extLst>
-                    <a:ext uri="{FF2B5EF4-FFF2-40B4-BE49-F238E27FC236}">
-                      <a16:creationId xmlns:a16="http://schemas.microsoft.com/office/drawing/2014/main" id="{50890A7E-3E8E-40DC-5A24-2A0FA315302E}"/>
-                    </a:ext>
-                  </a:extLst>
-                </p:cNvPr>
-                <p:cNvSpPr/>
-                <p:nvPr/>
-              </p:nvSpPr>
-              <p:spPr>
-                <a:xfrm rot="21313542">
-                  <a:off x="6816450" y="3167993"/>
-                  <a:ext cx="108000" cy="108000"/>
-                </a:xfrm>
-                <a:prstGeom prst="ellipse">
-                  <a:avLst/>
-                </a:prstGeom>
-                <a:grpFill/>
-                <a:ln w="12700" cap="flat" cmpd="sng" algn="ctr">
-                  <a:solidFill>
-                    <a:schemeClr val="bg1">
-                      <a:lumMod val="75000"/>
-                    </a:schemeClr>
-                  </a:solidFill>
-                  <a:prstDash val="solid"/>
-                  <a:miter lim="800000"/>
-                </a:ln>
-                <a:effectLst/>
-              </p:spPr>
-              <p:txBody>
-                <a:bodyPr rtlCol="0" anchor="ctr"/>
-                <a:lstStyle/>
-                <a:p>
-                  <a:pPr marL="0" marR="0" lvl="0" indent="0" algn="ctr" defTabSz="914400" eaLnBrk="1" fontAlgn="auto" latinLnBrk="0" hangingPunct="1">
-                    <a:lnSpc>
-                      <a:spcPct val="100000"/>
-                    </a:lnSpc>
-                    <a:spcBef>
-                      <a:spcPts val="0"/>
-                    </a:spcBef>
-                    <a:spcAft>
-                      <a:spcPts val="0"/>
-                    </a:spcAft>
-                    <a:buClrTx/>
-                    <a:buSzTx/>
-                    <a:buFontTx/>
-                    <a:buNone/>
-                    <a:tabLst/>
-                    <a:defRPr/>
-                  </a:pPr>
-                  <a:r>
-                    <a:rPr kumimoji="0" lang="de-DE" sz="600" b="0" i="0" u="none" strike="noStrike" kern="0" cap="none" spc="0" normalizeH="0" baseline="0">
-                      <a:ln>
-                        <a:noFill/>
-                      </a:ln>
-                      <a:solidFill>
-                        <a:schemeClr val="accent2"/>
-                      </a:solidFill>
-                      <a:effectLst/>
-                      <a:uLnTx/>
-                      <a:uFillTx/>
-                      <a:latin typeface="Montserrat Light"/>
-                      <a:ea typeface="+mn-ea"/>
-                      <a:cs typeface="Cordia New"/>
-                    </a:rPr>
-                    <a:t>4</a:t>
-                  </a:r>
-                </a:p>
-              </p:txBody>
-            </p:sp>
-            <p:sp>
-              <p:nvSpPr>
-                <p:cNvPr id="21" name="Oval 43">
-                  <a:extLst>
-                    <a:ext uri="{FF2B5EF4-FFF2-40B4-BE49-F238E27FC236}">
-                      <a16:creationId xmlns:a16="http://schemas.microsoft.com/office/drawing/2014/main" id="{8F494967-AFF3-F77A-41DE-A97DAA22A44A}"/>
-                    </a:ext>
-                  </a:extLst>
-                </p:cNvPr>
-                <p:cNvSpPr/>
-                <p:nvPr/>
-              </p:nvSpPr>
-              <p:spPr>
-                <a:xfrm>
-                  <a:off x="6820758" y="2995250"/>
-                  <a:ext cx="108000" cy="108000"/>
-                </a:xfrm>
-                <a:prstGeom prst="ellipse">
-                  <a:avLst/>
-                </a:prstGeom>
-                <a:grpFill/>
-                <a:ln w="12700" cap="flat" cmpd="sng" algn="ctr">
-                  <a:solidFill>
-                    <a:schemeClr val="bg1">
-                      <a:lumMod val="75000"/>
-                    </a:schemeClr>
-                  </a:solidFill>
-                  <a:prstDash val="solid"/>
-                  <a:miter lim="800000"/>
-                </a:ln>
-                <a:effectLst/>
-              </p:spPr>
-              <p:txBody>
-                <a:bodyPr lIns="0" rIns="0" rtlCol="0" anchor="ctr"/>
-                <a:lstStyle/>
-                <a:p>
-                  <a:pPr marL="0" marR="0" lvl="0" indent="0" algn="ctr" defTabSz="914400" fontAlgn="auto" latinLnBrk="0" hangingPunct="1">
-                    <a:lnSpc>
-                      <a:spcPct val="100000"/>
-                    </a:lnSpc>
-                    <a:spcBef>
-                      <a:spcPts val="0"/>
-                    </a:spcBef>
-                    <a:spcAft>
-                      <a:spcPts val="0"/>
-                    </a:spcAft>
-                    <a:buClrTx/>
-                    <a:buSzTx/>
-                    <a:buFontTx/>
-                    <a:buNone/>
-                    <a:tabLst/>
-                    <a:defRPr/>
-                  </a:pPr>
-                  <a:endParaRPr kumimoji="0" lang="de-DE" sz="600" b="0" i="0" u="none" strike="noStrike" kern="0" cap="none" spc="0" normalizeH="0" baseline="0">
-                    <a:ln>
-                      <a:noFill/>
-                    </a:ln>
-                    <a:solidFill>
-                      <a:schemeClr val="accent2"/>
-                    </a:solidFill>
-                    <a:effectLst/>
-                    <a:uLnTx/>
-                    <a:uFillTx/>
-                    <a:latin typeface="Montserrat Light"/>
-                    <a:ea typeface="+mn-ea"/>
-                    <a:cs typeface="Cordia New"/>
-                  </a:endParaRPr>
-                </a:p>
-              </p:txBody>
-            </p:sp>
-            <p:sp>
-              <p:nvSpPr>
-                <p:cNvPr id="22" name="Oval 44">
-                  <a:extLst>
-                    <a:ext uri="{FF2B5EF4-FFF2-40B4-BE49-F238E27FC236}">
-                      <a16:creationId xmlns:a16="http://schemas.microsoft.com/office/drawing/2014/main" id="{522DE157-BA4D-B827-C05A-1DD7946BBEF0}"/>
-                    </a:ext>
-                  </a:extLst>
-                </p:cNvPr>
-                <p:cNvSpPr/>
-                <p:nvPr/>
-              </p:nvSpPr>
-              <p:spPr>
-                <a:xfrm>
-                  <a:off x="7221657" y="2951964"/>
-                  <a:ext cx="216000" cy="216000"/>
-                </a:xfrm>
-                <a:prstGeom prst="ellipse">
-                  <a:avLst/>
-                </a:prstGeom>
-                <a:grpFill/>
-                <a:ln w="12700" cap="flat" cmpd="sng" algn="ctr">
-                  <a:solidFill>
-                    <a:schemeClr val="bg1">
-                      <a:lumMod val="75000"/>
-                    </a:schemeClr>
-                  </a:solidFill>
-                  <a:prstDash val="solid"/>
-                  <a:miter lim="800000"/>
-                </a:ln>
-                <a:effectLst/>
-              </p:spPr>
-              <p:txBody>
-                <a:bodyPr lIns="0" rIns="0" rtlCol="0" anchor="ctr"/>
-                <a:lstStyle/>
-                <a:p>
-                  <a:pPr marL="0" marR="0" lvl="0" indent="0" algn="ctr" defTabSz="914400" eaLnBrk="1" fontAlgn="auto" latinLnBrk="0" hangingPunct="1">
-                    <a:lnSpc>
-                      <a:spcPct val="100000"/>
-                    </a:lnSpc>
-                    <a:spcBef>
-                      <a:spcPts val="0"/>
-                    </a:spcBef>
-                    <a:spcAft>
-                      <a:spcPts val="0"/>
-                    </a:spcAft>
-                    <a:buClrTx/>
-                    <a:buSzTx/>
-                    <a:buFontTx/>
-                    <a:buNone/>
-                    <a:tabLst/>
-                    <a:defRPr/>
-                  </a:pPr>
-                  <a:r>
-                    <a:rPr kumimoji="0" lang="de-DE" sz="600" b="0" i="0" u="none" strike="noStrike" kern="0" cap="none" spc="0" normalizeH="0" baseline="0">
-                      <a:ln>
-                        <a:noFill/>
-                      </a:ln>
-                      <a:solidFill>
-                        <a:schemeClr val="accent2"/>
-                      </a:solidFill>
-                      <a:effectLst/>
-                      <a:uLnTx/>
-                      <a:uFillTx/>
-                      <a:latin typeface="Montserrat Light"/>
-                      <a:ea typeface="+mn-ea"/>
-                      <a:cs typeface="Cordia New"/>
-                    </a:rPr>
-                    <a:t>7</a:t>
-                  </a:r>
-                </a:p>
-              </p:txBody>
-            </p:sp>
-            <p:sp>
-              <p:nvSpPr>
-                <p:cNvPr id="23" name="Oval 45">
-                  <a:extLst>
-                    <a:ext uri="{FF2B5EF4-FFF2-40B4-BE49-F238E27FC236}">
-                      <a16:creationId xmlns:a16="http://schemas.microsoft.com/office/drawing/2014/main" id="{AF398262-44BB-A824-3A37-045E8EF1307C}"/>
-                    </a:ext>
-                  </a:extLst>
-                </p:cNvPr>
-                <p:cNvSpPr/>
-                <p:nvPr/>
-              </p:nvSpPr>
-              <p:spPr>
-                <a:xfrm>
-                  <a:off x="7088564" y="3110329"/>
-                  <a:ext cx="144000" cy="144000"/>
-                </a:xfrm>
-                <a:prstGeom prst="ellipse">
-                  <a:avLst/>
-                </a:prstGeom>
-                <a:grpFill/>
-                <a:ln w="12700" cap="flat" cmpd="sng" algn="ctr">
-                  <a:solidFill>
-                    <a:schemeClr val="bg1">
-                      <a:lumMod val="75000"/>
-                    </a:schemeClr>
-                  </a:solidFill>
-                  <a:prstDash val="solid"/>
-                  <a:miter lim="800000"/>
-                </a:ln>
-                <a:effectLst/>
-              </p:spPr>
-              <p:txBody>
-                <a:bodyPr lIns="0" rIns="0" rtlCol="0" anchor="ctr"/>
-                <a:lstStyle/>
-                <a:p>
-                  <a:pPr marL="0" marR="0" lvl="0" indent="0" algn="ctr" defTabSz="914400" eaLnBrk="1" fontAlgn="auto" latinLnBrk="0" hangingPunct="1">
-                    <a:lnSpc>
-                      <a:spcPct val="100000"/>
-                    </a:lnSpc>
-                    <a:spcBef>
-                      <a:spcPts val="0"/>
-                    </a:spcBef>
-                    <a:spcAft>
-                      <a:spcPts val="0"/>
-                    </a:spcAft>
-                    <a:buClrTx/>
-                    <a:buSzTx/>
-                    <a:buFontTx/>
-                    <a:buNone/>
-                    <a:tabLst/>
-                    <a:defRPr/>
-                  </a:pPr>
-                  <a:r>
-                    <a:rPr kumimoji="0" lang="de-DE" sz="600" b="0" i="0" u="none" strike="noStrike" kern="0" cap="none" spc="0" normalizeH="0" baseline="0">
-                      <a:ln>
-                        <a:noFill/>
-                      </a:ln>
-                      <a:solidFill>
-                        <a:schemeClr val="accent2"/>
-                      </a:solidFill>
-                      <a:effectLst/>
-                      <a:uLnTx/>
-                      <a:uFillTx/>
-                      <a:latin typeface="Montserrat Light"/>
-                      <a:ea typeface="+mn-ea"/>
-                      <a:cs typeface="Cordia New"/>
-                    </a:rPr>
-                    <a:t>8</a:t>
-                  </a:r>
-                </a:p>
-              </p:txBody>
-            </p:sp>
-            <p:sp>
-              <p:nvSpPr>
-                <p:cNvPr id="24" name="Oval 46">
-                  <a:extLst>
-                    <a:ext uri="{FF2B5EF4-FFF2-40B4-BE49-F238E27FC236}">
-                      <a16:creationId xmlns:a16="http://schemas.microsoft.com/office/drawing/2014/main" id="{7083D073-8A1E-B8CD-63FE-D5C7FB343CC8}"/>
-                    </a:ext>
-                  </a:extLst>
-                </p:cNvPr>
-                <p:cNvSpPr/>
-                <p:nvPr/>
-              </p:nvSpPr>
-              <p:spPr>
-                <a:xfrm>
-                  <a:off x="7414330" y="3086393"/>
-                  <a:ext cx="288000" cy="288000"/>
-                </a:xfrm>
-                <a:prstGeom prst="ellipse">
-                  <a:avLst/>
-                </a:prstGeom>
-                <a:grpFill/>
-                <a:ln w="12700" cap="flat" cmpd="sng" algn="ctr">
-                  <a:solidFill>
-                    <a:schemeClr val="bg1">
-                      <a:lumMod val="75000"/>
-                    </a:schemeClr>
-                  </a:solidFill>
-                  <a:prstDash val="solid"/>
-                  <a:miter lim="800000"/>
-                </a:ln>
-                <a:effectLst/>
-              </p:spPr>
-              <p:txBody>
-                <a:bodyPr rtlCol="0" anchor="ctr"/>
-                <a:lstStyle/>
-                <a:p>
-                  <a:pPr marL="0" marR="0" lvl="0" indent="0" algn="ctr" defTabSz="914400" eaLnBrk="1" fontAlgn="auto" latinLnBrk="0" hangingPunct="1">
-                    <a:lnSpc>
-                      <a:spcPct val="100000"/>
-                    </a:lnSpc>
-                    <a:spcBef>
-                      <a:spcPts val="0"/>
-                    </a:spcBef>
-                    <a:spcAft>
-                      <a:spcPts val="0"/>
-                    </a:spcAft>
-                    <a:buClrTx/>
-                    <a:buSzTx/>
-                    <a:buFontTx/>
-                    <a:buNone/>
-                    <a:tabLst/>
-                    <a:defRPr/>
-                  </a:pPr>
-                  <a:r>
-                    <a:rPr kumimoji="0" lang="de-DE" sz="600" b="0" i="0" u="none" strike="noStrike" kern="0" cap="none" spc="0" normalizeH="0" baseline="0">
-                      <a:ln>
-                        <a:noFill/>
-                      </a:ln>
-                      <a:solidFill>
-                        <a:schemeClr val="accent2"/>
-                      </a:solidFill>
-                      <a:effectLst/>
-                      <a:uLnTx/>
-                      <a:uFillTx/>
-                      <a:latin typeface="Montserrat Light"/>
-                      <a:ea typeface="+mn-ea"/>
-                      <a:cs typeface="Cordia New"/>
-                    </a:rPr>
-                    <a:t>5</a:t>
-                  </a:r>
-                </a:p>
-              </p:txBody>
-            </p:sp>
-            <p:sp>
-              <p:nvSpPr>
-                <p:cNvPr id="25" name="Oval 47">
-                  <a:extLst>
-                    <a:ext uri="{FF2B5EF4-FFF2-40B4-BE49-F238E27FC236}">
-                      <a16:creationId xmlns:a16="http://schemas.microsoft.com/office/drawing/2014/main" id="{530E6EA2-6F03-7B79-71D2-A85226115B86}"/>
-                    </a:ext>
-                  </a:extLst>
-                </p:cNvPr>
-                <p:cNvSpPr/>
-                <p:nvPr/>
-              </p:nvSpPr>
-              <p:spPr>
-                <a:xfrm>
-                  <a:off x="7805989" y="3218784"/>
-                  <a:ext cx="108000" cy="108000"/>
-                </a:xfrm>
-                <a:prstGeom prst="ellipse">
-                  <a:avLst/>
-                </a:prstGeom>
-                <a:grpFill/>
-                <a:ln w="12700" cap="flat" cmpd="sng" algn="ctr">
-                  <a:solidFill>
-                    <a:schemeClr val="bg1">
-                      <a:lumMod val="75000"/>
-                    </a:schemeClr>
-                  </a:solidFill>
-                  <a:prstDash val="solid"/>
-                  <a:miter lim="800000"/>
-                </a:ln>
-                <a:effectLst/>
-              </p:spPr>
-              <p:txBody>
-                <a:bodyPr lIns="0" rIns="0" rtlCol="0" anchor="ctr"/>
-                <a:lstStyle/>
-                <a:p>
-                  <a:pPr marL="0" marR="0" lvl="0" indent="0" algn="ctr" defTabSz="914400" eaLnBrk="1" fontAlgn="auto" latinLnBrk="0" hangingPunct="1">
-                    <a:lnSpc>
-                      <a:spcPct val="100000"/>
-                    </a:lnSpc>
-                    <a:spcBef>
-                      <a:spcPts val="0"/>
-                    </a:spcBef>
-                    <a:spcAft>
-                      <a:spcPts val="0"/>
-                    </a:spcAft>
-                    <a:buClrTx/>
-                    <a:buSzTx/>
-                    <a:buFontTx/>
-                    <a:buNone/>
-                    <a:tabLst/>
-                    <a:defRPr/>
-                  </a:pPr>
-                  <a:endParaRPr kumimoji="0" lang="de-DE" sz="600" b="0" i="0" u="none" strike="noStrike" kern="0" cap="none" spc="0" normalizeH="0" baseline="0">
-                    <a:ln>
-                      <a:noFill/>
-                    </a:ln>
-                    <a:solidFill>
-                      <a:schemeClr val="accent2"/>
-                    </a:solidFill>
-                    <a:effectLst/>
-                    <a:uLnTx/>
-                    <a:uFillTx/>
-                    <a:latin typeface="Montserrat Light"/>
-                    <a:ea typeface="+mn-ea"/>
-                    <a:cs typeface="Cordia New"/>
-                  </a:endParaRPr>
-                </a:p>
-              </p:txBody>
-            </p:sp>
-            <p:sp>
-              <p:nvSpPr>
-                <p:cNvPr id="26" name="Oval 48">
-                  <a:extLst>
-                    <a:ext uri="{FF2B5EF4-FFF2-40B4-BE49-F238E27FC236}">
-                      <a16:creationId xmlns:a16="http://schemas.microsoft.com/office/drawing/2014/main" id="{AF938FC7-0B24-927A-3D3F-F3CB1BA20095}"/>
-                    </a:ext>
-                  </a:extLst>
-                </p:cNvPr>
-                <p:cNvSpPr/>
-                <p:nvPr/>
-              </p:nvSpPr>
-              <p:spPr>
-                <a:xfrm>
-                  <a:off x="7856270" y="3043042"/>
-                  <a:ext cx="108000" cy="108000"/>
-                </a:xfrm>
-                <a:prstGeom prst="ellipse">
-                  <a:avLst/>
-                </a:prstGeom>
-                <a:grpFill/>
-                <a:ln w="12700" cap="flat" cmpd="sng" algn="ctr">
-                  <a:solidFill>
-                    <a:schemeClr val="bg1">
-                      <a:lumMod val="75000"/>
-                    </a:schemeClr>
-                  </a:solidFill>
-                  <a:prstDash val="solid"/>
-                  <a:miter lim="800000"/>
-                </a:ln>
-                <a:effectLst/>
-              </p:spPr>
-              <p:txBody>
-                <a:bodyPr lIns="0" rIns="0" rtlCol="0" anchor="ctr"/>
-                <a:lstStyle/>
-                <a:p>
-                  <a:pPr marL="0" marR="0" lvl="0" indent="0" algn="ctr" defTabSz="914400" eaLnBrk="1" fontAlgn="auto" latinLnBrk="0" hangingPunct="1">
-                    <a:lnSpc>
-                      <a:spcPct val="100000"/>
-                    </a:lnSpc>
-                    <a:spcBef>
-                      <a:spcPts val="0"/>
-                    </a:spcBef>
-                    <a:spcAft>
-                      <a:spcPts val="0"/>
-                    </a:spcAft>
-                    <a:buClrTx/>
-                    <a:buSzTx/>
-                    <a:buFontTx/>
-                    <a:buNone/>
-                    <a:tabLst/>
-                    <a:defRPr/>
-                  </a:pPr>
-                  <a:r>
-                    <a:rPr kumimoji="0" lang="de-DE" sz="600" b="0" i="0" u="none" strike="noStrike" kern="0" cap="none" spc="0" normalizeH="0" baseline="0">
-                      <a:ln>
-                        <a:noFill/>
-                      </a:ln>
-                      <a:solidFill>
-                        <a:schemeClr val="accent2"/>
-                      </a:solidFill>
-                      <a:effectLst/>
-                      <a:uLnTx/>
-                      <a:uFillTx/>
-                      <a:latin typeface="Montserrat Light"/>
-                      <a:ea typeface="+mn-ea"/>
-                      <a:cs typeface="Cordia New"/>
-                    </a:rPr>
-                    <a:t>9</a:t>
-                  </a:r>
-                </a:p>
-              </p:txBody>
-            </p:sp>
-            <p:sp>
-              <p:nvSpPr>
-                <p:cNvPr id="27" name="Oval 49">
-                  <a:extLst>
-                    <a:ext uri="{FF2B5EF4-FFF2-40B4-BE49-F238E27FC236}">
-                      <a16:creationId xmlns:a16="http://schemas.microsoft.com/office/drawing/2014/main" id="{F7FF89DB-ACB4-267A-EB54-C53DAC11B03E}"/>
-                    </a:ext>
-                  </a:extLst>
-                </p:cNvPr>
-                <p:cNvSpPr/>
-                <p:nvPr/>
-              </p:nvSpPr>
-              <p:spPr>
-                <a:xfrm>
-                  <a:off x="8036622" y="3122393"/>
-                  <a:ext cx="216000" cy="216000"/>
-                </a:xfrm>
-                <a:prstGeom prst="ellipse">
-                  <a:avLst/>
-                </a:prstGeom>
-                <a:grpFill/>
-                <a:ln w="12700" cap="flat" cmpd="sng" algn="ctr">
-                  <a:solidFill>
-                    <a:schemeClr val="bg1">
-                      <a:lumMod val="75000"/>
-                    </a:schemeClr>
-                  </a:solidFill>
-                  <a:prstDash val="solid"/>
-                  <a:miter lim="800000"/>
-                </a:ln>
-                <a:effectLst/>
-              </p:spPr>
-              <p:txBody>
-                <a:bodyPr lIns="0" tIns="45720" rIns="0" bIns="45720" rtlCol="0" anchor="ctr"/>
-                <a:lstStyle/>
-                <a:p>
-                  <a:pPr marL="0" marR="0" lvl="0" indent="0" algn="ctr" defTabSz="914400" eaLnBrk="1" fontAlgn="auto" latinLnBrk="0" hangingPunct="1">
-                    <a:lnSpc>
-                      <a:spcPct val="100000"/>
-                    </a:lnSpc>
-                    <a:spcBef>
-                      <a:spcPts val="0"/>
-                    </a:spcBef>
-                    <a:spcAft>
-                      <a:spcPts val="0"/>
-                    </a:spcAft>
-                    <a:buClrTx/>
-                    <a:buSzTx/>
-                    <a:buFontTx/>
-                    <a:buNone/>
-                    <a:tabLst/>
-                    <a:defRPr/>
-                  </a:pPr>
-                  <a:r>
-                    <a:rPr kumimoji="0" lang="de-DE" sz="600" b="0" i="0" u="none" strike="noStrike" kern="0" cap="none" spc="0" normalizeH="0" baseline="0">
-                      <a:ln>
-                        <a:noFill/>
-                      </a:ln>
-                      <a:solidFill>
-                        <a:schemeClr val="accent2"/>
-                      </a:solidFill>
-                      <a:effectLst/>
-                      <a:uLnTx/>
-                      <a:uFillTx/>
-                      <a:latin typeface="Montserrat Light"/>
-                      <a:cs typeface="Cordia New"/>
-                    </a:rPr>
-                    <a:t>11</a:t>
-                  </a:r>
-                  <a:endParaRPr lang="de-DE" sz="600" b="0" i="0" u="none" strike="noStrike" kern="0" cap="none" spc="0" normalizeH="0" baseline="0">
-                    <a:ln>
-                      <a:noFill/>
-                    </a:ln>
-                    <a:solidFill>
-                      <a:schemeClr val="accent2"/>
-                    </a:solidFill>
-                    <a:effectLst/>
-                    <a:uLnTx/>
-                    <a:uFillTx/>
-                    <a:latin typeface="Montserrat Light"/>
-                    <a:cs typeface="Cordia New"/>
-                  </a:endParaRPr>
-                </a:p>
-              </p:txBody>
-            </p:sp>
-            <p:sp>
-              <p:nvSpPr>
-                <p:cNvPr id="28" name="Oval 50">
-                  <a:extLst>
-                    <a:ext uri="{FF2B5EF4-FFF2-40B4-BE49-F238E27FC236}">
-                      <a16:creationId xmlns:a16="http://schemas.microsoft.com/office/drawing/2014/main" id="{36C78313-887E-945E-C357-0C43C036E7F8}"/>
-                    </a:ext>
-                  </a:extLst>
-                </p:cNvPr>
-                <p:cNvSpPr/>
-                <p:nvPr/>
-              </p:nvSpPr>
-              <p:spPr>
-                <a:xfrm>
-                  <a:off x="9233419" y="3137400"/>
-                  <a:ext cx="72000" cy="72000"/>
-                </a:xfrm>
-                <a:prstGeom prst="ellipse">
-                  <a:avLst/>
-                </a:prstGeom>
-                <a:grpFill/>
-                <a:ln w="12700" cap="flat" cmpd="sng" algn="ctr">
-                  <a:solidFill>
-                    <a:schemeClr val="bg1">
-                      <a:lumMod val="75000"/>
-                    </a:schemeClr>
-                  </a:solidFill>
-                  <a:prstDash val="solid"/>
-                  <a:miter lim="800000"/>
-                </a:ln>
-                <a:effectLst/>
-              </p:spPr>
-              <p:txBody>
-                <a:bodyPr lIns="0" rIns="0" rtlCol="0" anchor="ctr"/>
-                <a:lstStyle/>
-                <a:p>
-                  <a:pPr marL="0" marR="0" lvl="0" indent="0" algn="ctr" defTabSz="914400" eaLnBrk="1" fontAlgn="auto" latinLnBrk="0" hangingPunct="1">
-                    <a:lnSpc>
-                      <a:spcPct val="100000"/>
-                    </a:lnSpc>
-                    <a:spcBef>
-                      <a:spcPts val="0"/>
-                    </a:spcBef>
-                    <a:spcAft>
-                      <a:spcPts val="0"/>
-                    </a:spcAft>
-                    <a:buClrTx/>
-                    <a:buSzTx/>
-                    <a:buFontTx/>
-                    <a:buNone/>
-                    <a:tabLst/>
-                    <a:defRPr/>
-                  </a:pPr>
-                  <a:r>
-                    <a:rPr kumimoji="0" lang="de-DE" sz="600" b="0" i="0" u="none" strike="noStrike" kern="0" cap="none" spc="0" normalizeH="0" baseline="0">
-                      <a:ln>
-                        <a:noFill/>
-                      </a:ln>
-                      <a:solidFill>
-                        <a:schemeClr val="accent2"/>
-                      </a:solidFill>
-                      <a:effectLst/>
-                      <a:uLnTx/>
-                      <a:uFillTx/>
-                      <a:latin typeface="Montserrat Light"/>
-                      <a:ea typeface="+mn-ea"/>
-                      <a:cs typeface="Cordia New"/>
-                    </a:rPr>
-                    <a:t>14</a:t>
-                  </a:r>
-                </a:p>
-              </p:txBody>
-            </p:sp>
-            <p:sp>
-              <p:nvSpPr>
-                <p:cNvPr id="29" name="Oval 51">
-                  <a:extLst>
-                    <a:ext uri="{FF2B5EF4-FFF2-40B4-BE49-F238E27FC236}">
-                      <a16:creationId xmlns:a16="http://schemas.microsoft.com/office/drawing/2014/main" id="{0E59AD54-1813-004C-D41E-16EA425E0F96}"/>
-                    </a:ext>
-                  </a:extLst>
-                </p:cNvPr>
-                <p:cNvSpPr/>
-                <p:nvPr/>
-              </p:nvSpPr>
-              <p:spPr>
-                <a:xfrm>
-                  <a:off x="8442537" y="2977713"/>
-                  <a:ext cx="72000" cy="72000"/>
-                </a:xfrm>
-                <a:prstGeom prst="ellipse">
-                  <a:avLst/>
-                </a:prstGeom>
-                <a:grpFill/>
-                <a:ln w="12700" cap="flat" cmpd="sng" algn="ctr">
-                  <a:solidFill>
-                    <a:schemeClr val="bg1">
-                      <a:lumMod val="75000"/>
-                    </a:schemeClr>
-                  </a:solidFill>
-                  <a:prstDash val="solid"/>
-                  <a:miter lim="800000"/>
-                </a:ln>
-                <a:effectLst/>
-              </p:spPr>
-              <p:txBody>
-                <a:bodyPr lIns="0" rIns="0" rtlCol="0" anchor="ctr"/>
-                <a:lstStyle/>
-                <a:p>
-                  <a:pPr marL="0" marR="0" lvl="0" indent="0" algn="ctr" defTabSz="914400" eaLnBrk="1" fontAlgn="auto" latinLnBrk="0" hangingPunct="1">
-                    <a:lnSpc>
-                      <a:spcPct val="100000"/>
-                    </a:lnSpc>
-                    <a:spcBef>
-                      <a:spcPts val="0"/>
-                    </a:spcBef>
-                    <a:spcAft>
-                      <a:spcPts val="0"/>
-                    </a:spcAft>
-                    <a:buClrTx/>
-                    <a:buSzTx/>
-                    <a:buFontTx/>
-                    <a:buNone/>
-                    <a:tabLst/>
-                    <a:defRPr/>
-                  </a:pPr>
-                  <a:r>
-                    <a:rPr kumimoji="0" lang="de-DE" sz="400" b="0" i="0" u="none" strike="noStrike" kern="0" cap="none" spc="0" normalizeH="0" baseline="0">
-                      <a:ln>
-                        <a:noFill/>
-                      </a:ln>
-                      <a:solidFill>
-                        <a:schemeClr val="accent2"/>
-                      </a:solidFill>
-                      <a:effectLst/>
-                      <a:uLnTx/>
-                      <a:uFillTx/>
-                      <a:latin typeface="Montserrat Light"/>
-                      <a:ea typeface="+mn-ea"/>
-                      <a:cs typeface="Cordia New"/>
-                    </a:rPr>
-                    <a:t>12</a:t>
-                  </a:r>
-                </a:p>
-              </p:txBody>
-            </p:sp>
-            <p:sp>
-              <p:nvSpPr>
-                <p:cNvPr id="30" name="Oval 52">
-                  <a:extLst>
-                    <a:ext uri="{FF2B5EF4-FFF2-40B4-BE49-F238E27FC236}">
-                      <a16:creationId xmlns:a16="http://schemas.microsoft.com/office/drawing/2014/main" id="{FF44BEC3-5DC8-5214-658E-4C2278D685F6}"/>
-                    </a:ext>
-                  </a:extLst>
-                </p:cNvPr>
-                <p:cNvSpPr/>
-                <p:nvPr/>
-              </p:nvSpPr>
-              <p:spPr>
-                <a:xfrm>
-                  <a:off x="8594937" y="3130113"/>
-                  <a:ext cx="72000" cy="72000"/>
-                </a:xfrm>
-                <a:prstGeom prst="ellipse">
-                  <a:avLst/>
-                </a:prstGeom>
-                <a:grpFill/>
-                <a:ln w="12700" cap="flat" cmpd="sng" algn="ctr">
-                  <a:solidFill>
-                    <a:schemeClr val="bg1">
-                      <a:lumMod val="75000"/>
-                    </a:schemeClr>
-                  </a:solidFill>
-                  <a:prstDash val="solid"/>
-                  <a:miter lim="800000"/>
-                </a:ln>
-                <a:effectLst/>
-              </p:spPr>
-              <p:txBody>
-                <a:bodyPr lIns="0" rIns="0" rtlCol="0" anchor="ctr"/>
-                <a:lstStyle/>
-                <a:p>
-                  <a:pPr marL="0" marR="0" lvl="0" indent="0" algn="ctr" defTabSz="914400" eaLnBrk="1" fontAlgn="auto" latinLnBrk="0" hangingPunct="1">
-                    <a:lnSpc>
-                      <a:spcPct val="100000"/>
-                    </a:lnSpc>
-                    <a:spcBef>
-                      <a:spcPts val="0"/>
-                    </a:spcBef>
-                    <a:spcAft>
-                      <a:spcPts val="0"/>
-                    </a:spcAft>
-                    <a:buClrTx/>
-                    <a:buSzTx/>
-                    <a:buFontTx/>
-                    <a:buNone/>
-                    <a:tabLst/>
-                    <a:defRPr/>
-                  </a:pPr>
-                  <a:r>
-                    <a:rPr kumimoji="0" lang="de-DE" sz="400" b="0" i="0" u="none" strike="noStrike" kern="0" cap="none" spc="0" normalizeH="0" baseline="0">
-                      <a:ln>
-                        <a:noFill/>
-                      </a:ln>
-                      <a:solidFill>
-                        <a:schemeClr val="accent2"/>
-                      </a:solidFill>
-                      <a:effectLst/>
-                      <a:uLnTx/>
-                      <a:uFillTx/>
-                      <a:latin typeface="Montserrat Light"/>
-                      <a:ea typeface="+mn-ea"/>
-                      <a:cs typeface="Cordia New"/>
-                    </a:rPr>
-                    <a:t>13</a:t>
-                  </a:r>
-                </a:p>
-              </p:txBody>
-            </p:sp>
-            <p:sp>
-              <p:nvSpPr>
-                <p:cNvPr id="31" name="Oval 53">
-                  <a:extLst>
-                    <a:ext uri="{FF2B5EF4-FFF2-40B4-BE49-F238E27FC236}">
-                      <a16:creationId xmlns:a16="http://schemas.microsoft.com/office/drawing/2014/main" id="{65144DE4-622A-660F-1601-8541E1BF16BD}"/>
-                    </a:ext>
-                  </a:extLst>
-                </p:cNvPr>
-                <p:cNvSpPr/>
-                <p:nvPr/>
-              </p:nvSpPr>
-              <p:spPr>
-                <a:xfrm>
-                  <a:off x="6933904" y="3076684"/>
-                  <a:ext cx="108000" cy="108000"/>
-                </a:xfrm>
-                <a:prstGeom prst="ellipse">
-                  <a:avLst/>
-                </a:prstGeom>
-                <a:grpFill/>
-                <a:ln w="12700" cap="flat" cmpd="sng" algn="ctr">
-                  <a:solidFill>
-                    <a:schemeClr val="bg1">
-                      <a:lumMod val="75000"/>
-                    </a:schemeClr>
-                  </a:solidFill>
-                  <a:prstDash val="solid"/>
-                  <a:miter lim="800000"/>
-                </a:ln>
-                <a:effectLst/>
-              </p:spPr>
-              <p:txBody>
-                <a:bodyPr rtlCol="0" anchor="ctr"/>
-                <a:lstStyle/>
-                <a:p>
-                  <a:pPr marL="0" marR="0" lvl="0" indent="0" algn="ctr" defTabSz="914400" eaLnBrk="1" fontAlgn="auto" latinLnBrk="0" hangingPunct="1">
-                    <a:lnSpc>
-                      <a:spcPct val="100000"/>
-                    </a:lnSpc>
-                    <a:spcBef>
-                      <a:spcPts val="0"/>
-                    </a:spcBef>
-                    <a:spcAft>
-                      <a:spcPts val="0"/>
-                    </a:spcAft>
-                    <a:buClrTx/>
-                    <a:buSzTx/>
-                    <a:buFontTx/>
-                    <a:buNone/>
-                    <a:tabLst/>
-                    <a:defRPr/>
-                  </a:pPr>
-                  <a:r>
-                    <a:rPr kumimoji="0" lang="de-DE" sz="600" b="0" i="0" u="none" strike="noStrike" kern="0" cap="none" spc="0" normalizeH="0" baseline="0">
-                      <a:ln>
-                        <a:noFill/>
-                      </a:ln>
-                      <a:solidFill>
-                        <a:schemeClr val="accent2"/>
-                      </a:solidFill>
-                      <a:effectLst/>
-                      <a:uLnTx/>
-                      <a:uFillTx/>
-                      <a:latin typeface="Montserrat Light"/>
-                      <a:ea typeface="+mn-ea"/>
-                      <a:cs typeface="Cordia New"/>
-                    </a:rPr>
-                    <a:t>2</a:t>
-                  </a:r>
-                </a:p>
-              </p:txBody>
-            </p:sp>
-          </p:grpSp>
-          <p:sp>
-            <p:nvSpPr>
-              <p:cNvPr id="15" name="Rectangle 5">
-                <a:extLst>
-                  <a:ext uri="{FF2B5EF4-FFF2-40B4-BE49-F238E27FC236}">
-                    <a16:creationId xmlns:a16="http://schemas.microsoft.com/office/drawing/2014/main" id="{2038D86E-F628-E0C3-B4AD-1C6418AE7398}"/>
-                  </a:ext>
-                </a:extLst>
-              </p:cNvPr>
-              <p:cNvSpPr txBox="1">
-                <a:spLocks noChangeArrowheads="1"/>
-              </p:cNvSpPr>
-              <p:nvPr/>
-            </p:nvSpPr>
-            <p:spPr>
-              <a:xfrm>
-                <a:off x="6857919" y="3650179"/>
-                <a:ext cx="4812073" cy="67427"/>
-              </a:xfrm>
-              <a:prstGeom prst="rect">
-                <a:avLst/>
-              </a:prstGeom>
-              <a:noFill/>
-              <a:ln/>
-            </p:spPr>
-            <p:txBody>
-              <a:bodyPr vert="horz" wrap="square" lIns="0" tIns="0" rIns="0" bIns="0" rtlCol="0" anchor="ctr">
-                <a:spAutoFit/>
-              </a:bodyPr>
-              <a:lstStyle/>
-              <a:p>
-                <a:pPr>
-                  <a:lnSpc>
-                    <a:spcPct val="90000"/>
-                  </a:lnSpc>
-                  <a:spcBef>
-                    <a:spcPts val="400"/>
-                  </a:spcBef>
-                  <a:buClr>
-                    <a:srgbClr val="000000"/>
-                  </a:buClr>
-                  <a:buSzPct val="100000"/>
-                </a:pPr>
-                <a:r>
-                  <a:rPr lang="de-DE" sz="400">
-                    <a:solidFill>
-                      <a:schemeClr val="accent1"/>
-                    </a:solidFill>
-                  </a:rPr>
-                  <a:t>1-14: </a:t>
-                </a:r>
-                <a:r>
-                  <a:rPr lang="de-DE" sz="400" err="1">
-                    <a:solidFill>
-                      <a:schemeClr val="accent1"/>
-                    </a:solidFill>
-                  </a:rPr>
-                  <a:t>order</a:t>
-                </a:r>
-                <a:r>
-                  <a:rPr lang="de-DE" sz="400">
-                    <a:solidFill>
-                      <a:schemeClr val="accent1"/>
-                    </a:solidFill>
-                  </a:rPr>
-                  <a:t> </a:t>
-                </a:r>
-                <a:r>
-                  <a:rPr lang="de-DE" sz="400" err="1">
-                    <a:solidFill>
-                      <a:schemeClr val="accent1"/>
-                    </a:solidFill>
-                  </a:rPr>
-                  <a:t>of</a:t>
-                </a:r>
-                <a:r>
-                  <a:rPr lang="de-DE" sz="400">
-                    <a:solidFill>
-                      <a:schemeClr val="accent1"/>
-                    </a:solidFill>
-                  </a:rPr>
-                  <a:t> </a:t>
-                </a:r>
-                <a:r>
-                  <a:rPr lang="de-DE" sz="400" err="1">
-                    <a:solidFill>
-                      <a:schemeClr val="accent1"/>
-                    </a:solidFill>
-                  </a:rPr>
-                  <a:t>behaviour</a:t>
-                </a:r>
-                <a:r>
-                  <a:rPr lang="de-DE" sz="400">
-                    <a:solidFill>
-                      <a:schemeClr val="accent1"/>
-                    </a:solidFill>
-                  </a:rPr>
-                  <a:t>;  Circle </a:t>
-                </a:r>
-                <a:r>
-                  <a:rPr lang="de-DE" sz="400" err="1">
-                    <a:solidFill>
-                      <a:schemeClr val="accent1"/>
-                    </a:solidFill>
-                  </a:rPr>
-                  <a:t>size</a:t>
-                </a:r>
-                <a:r>
-                  <a:rPr lang="de-DE" sz="400">
-                    <a:solidFill>
-                      <a:schemeClr val="accent1"/>
-                    </a:solidFill>
-                  </a:rPr>
-                  <a:t>: </a:t>
-                </a:r>
-                <a:r>
-                  <a:rPr lang="de-DE" sz="400" err="1">
-                    <a:solidFill>
-                      <a:schemeClr val="accent1"/>
-                    </a:solidFill>
-                  </a:rPr>
-                  <a:t>weight</a:t>
-                </a:r>
-                <a:r>
-                  <a:rPr lang="de-DE" sz="400">
-                    <a:solidFill>
-                      <a:schemeClr val="accent1"/>
-                    </a:solidFill>
-                  </a:rPr>
-                  <a:t> </a:t>
-                </a:r>
-                <a:r>
-                  <a:rPr lang="de-DE" sz="400" err="1">
-                    <a:solidFill>
-                      <a:schemeClr val="accent1"/>
-                    </a:solidFill>
-                  </a:rPr>
-                  <a:t>of</a:t>
-                </a:r>
-                <a:r>
-                  <a:rPr lang="de-DE" sz="400">
-                    <a:solidFill>
-                      <a:schemeClr val="accent1"/>
-                    </a:solidFill>
-                  </a:rPr>
-                  <a:t> </a:t>
-                </a:r>
-                <a:r>
-                  <a:rPr lang="de-DE" sz="400" err="1">
-                    <a:solidFill>
-                      <a:schemeClr val="accent1"/>
-                    </a:solidFill>
-                  </a:rPr>
-                  <a:t>behavior</a:t>
-                </a:r>
-                <a:endParaRPr lang="de-DE" sz="400">
-                  <a:solidFill>
-                    <a:schemeClr val="accent1"/>
-                  </a:solidFill>
-                </a:endParaRPr>
-              </a:p>
-            </p:txBody>
-          </p:sp>
-        </p:grpSp>
-        <p:sp>
-          <p:nvSpPr>
-            <p:cNvPr id="13" name="Rectangle 27">
-              <a:extLst>
-                <a:ext uri="{FF2B5EF4-FFF2-40B4-BE49-F238E27FC236}">
-                  <a16:creationId xmlns:a16="http://schemas.microsoft.com/office/drawing/2014/main" id="{1E6DE68C-A9FB-2A23-4BE9-9D84F126DB2E}"/>
-                </a:ext>
-              </a:extLst>
-            </p:cNvPr>
-            <p:cNvSpPr>
-              <a:spLocks noChangeAspect="1"/>
-            </p:cNvSpPr>
-            <p:nvPr/>
-          </p:nvSpPr>
-          <p:spPr>
-            <a:xfrm>
-              <a:off x="6507861" y="2561583"/>
-              <a:ext cx="5011597" cy="1232316"/>
-            </a:xfrm>
-            <a:prstGeom prst="rect">
-              <a:avLst/>
-            </a:prstGeom>
-            <a:noFill/>
-            <a:ln w="9525" cap="flat" cmpd="sng" algn="ctr">
-              <a:noFill/>
-              <a:prstDash val="solid"/>
-            </a:ln>
-            <a:effectLst/>
-          </p:spPr>
-          <p:txBody>
-            <a:bodyPr lIns="72000" tIns="0" rIns="72000" bIns="0" rtlCol="0" anchor="ctr"/>
-            <a:lstStyle/>
-            <a:p>
-              <a:pPr marL="0" marR="0" lvl="0" indent="0" algn="ctr" defTabSz="914400" fontAlgn="base" latinLnBrk="0" hangingPunct="1">
-                <a:lnSpc>
-                  <a:spcPct val="90000"/>
-                </a:lnSpc>
-                <a:spcBef>
-                  <a:spcPts val="300"/>
-                </a:spcBef>
-                <a:spcAft>
-                  <a:spcPct val="0"/>
-                </a:spcAft>
-                <a:buClrTx/>
-                <a:buSzTx/>
-                <a:buFontTx/>
-                <a:buNone/>
-                <a:tabLst/>
-                <a:defRPr/>
-              </a:pPr>
-              <a:endParaRPr kumimoji="0" lang="de-DE" sz="1300" b="0" i="0" u="none" strike="noStrike" kern="0" cap="none" spc="0" normalizeH="0" baseline="0">
-                <a:ln>
-                  <a:noFill/>
-                </a:ln>
-                <a:solidFill>
-                  <a:srgbClr val="8D9399"/>
-                </a:solidFill>
-                <a:effectLst/>
-                <a:uLnTx/>
-                <a:uFillTx/>
-                <a:latin typeface="Arial Narrow"/>
-                <a:cs typeface="Arial" pitchFamily="34" charset="0"/>
-              </a:endParaRPr>
-            </a:p>
-          </p:txBody>
-        </p:sp>
-      </p:grpSp>
-      <p:sp>
-        <p:nvSpPr>
-          <p:cNvPr id="40" name="Rectangle 27">
-            <a:extLst>
-              <a:ext uri="{FF2B5EF4-FFF2-40B4-BE49-F238E27FC236}">
-                <a16:creationId xmlns:a16="http://schemas.microsoft.com/office/drawing/2014/main" id="{6D384436-0A42-1CAE-0CCA-7979C4071AA5}"/>
-              </a:ext>
-            </a:extLst>
-          </p:cNvPr>
-          <p:cNvSpPr>
-            <a:spLocks noChangeAspect="1"/>
-          </p:cNvSpPr>
-          <p:nvPr/>
-        </p:nvSpPr>
-        <p:spPr>
-          <a:xfrm>
-            <a:off x="917418" y="2026717"/>
-            <a:ext cx="2938080" cy="1137066"/>
-          </a:xfrm>
-          <a:prstGeom prst="rect">
-            <a:avLst/>
-          </a:prstGeom>
-          <a:noFill/>
-          <a:ln w="9525" cap="flat" cmpd="sng" algn="ctr">
-            <a:solidFill>
-              <a:srgbClr val="DEE0E3"/>
-            </a:solidFill>
-            <a:prstDash val="solid"/>
-          </a:ln>
-          <a:effectLst/>
-        </p:spPr>
-        <p:txBody>
-          <a:bodyPr lIns="72000" tIns="0" rIns="72000" bIns="0" rtlCol="0" anchor="ctr"/>
-          <a:lstStyle/>
-          <a:p>
-            <a:pPr marL="0" marR="0" lvl="0" indent="0" algn="ctr" defTabSz="914400" fontAlgn="base" latinLnBrk="0" hangingPunct="1">
-              <a:lnSpc>
-                <a:spcPct val="90000"/>
-              </a:lnSpc>
-              <a:spcBef>
-                <a:spcPts val="300"/>
-              </a:spcBef>
-              <a:spcAft>
-                <a:spcPct val="0"/>
-              </a:spcAft>
-              <a:buClrTx/>
-              <a:buSzTx/>
-              <a:buFontTx/>
-              <a:buNone/>
-              <a:tabLst/>
-              <a:defRPr/>
-            </a:pPr>
-            <a:endParaRPr kumimoji="0" lang="de-DE" sz="1300" b="0" i="0" u="none" strike="noStrike" kern="0" cap="none" spc="0" normalizeH="0" baseline="0">
-              <a:ln>
-                <a:noFill/>
-              </a:ln>
-              <a:solidFill>
-                <a:srgbClr val="8D9399"/>
-              </a:solidFill>
-              <a:effectLst/>
-              <a:uLnTx/>
-              <a:uFillTx/>
-              <a:latin typeface="Arial Narrow"/>
-              <a:cs typeface="Arial" pitchFamily="34" charset="0"/>
-            </a:endParaRPr>
-          </a:p>
-        </p:txBody>
-      </p:sp>
       <p:pic>
         <p:nvPicPr>
-          <p:cNvPr id="41" name="Picture 11" descr="A picture containing text, electronics, display, screenshot&#10;&#10;Description automatically generated">
+          <p:cNvPr id="48" name="ProjectPicture" descr="Project Picture">
             <a:extLst>
               <a:ext uri="{FF2B5EF4-FFF2-40B4-BE49-F238E27FC236}">
-                <a16:creationId xmlns:a16="http://schemas.microsoft.com/office/drawing/2014/main" id="{DDFDA1FC-ABD9-8080-7354-62D2E326B19F}"/>
+                <a16:creationId xmlns:a16="http://schemas.microsoft.com/office/drawing/2014/main" id="{4755247C-16B4-3D48-4BEE-3C21CA5B4563}"/>
               </a:ext>
             </a:extLst>
           </p:cNvPr>
@@ -5299,7 +3266,43 @@
           <p:nvPr/>
         </p:nvPicPr>
         <p:blipFill>
-          <a:blip r:embed="rId2">
+          <a:blip r:embed="rId3">
+            <a:extLst>
+              <a:ext uri="{28A0092B-C50C-407E-A947-70E740481C1C}">
+                <a14:useLocalDpi xmlns:a14="http://schemas.microsoft.com/office/drawing/2010/main" val="0"/>
+              </a:ext>
+            </a:extLst>
+          </a:blip>
+          <a:stretch>
+            <a:fillRect/>
+          </a:stretch>
+        </p:blipFill>
+        <p:spPr>
+          <a:xfrm>
+            <a:off x="852067" y="1612015"/>
+            <a:ext cx="3072816" cy="1921760"/>
+          </a:xfrm>
+          <a:prstGeom prst="rect">
+            <a:avLst/>
+          </a:prstGeom>
+        </p:spPr>
+      </p:pic>
+      <p:pic>
+        <p:nvPicPr>
+          <p:cNvPr id="50" name="Picture 11" descr="A picture containing text, electronics, display, screenshot  Description automatically generated">
+            <a:extLst>
+              <a:ext uri="{FF2B5EF4-FFF2-40B4-BE49-F238E27FC236}">
+                <a16:creationId xmlns:a16="http://schemas.microsoft.com/office/drawing/2014/main" id="{0658B6C7-75CB-65E0-E115-683BB687F654}"/>
+              </a:ext>
+            </a:extLst>
+          </p:cNvPr>
+          <p:cNvPicPr>
+            <a:picLocks noChangeAspect="1"/>
+          </p:cNvPicPr>
+          <p:nvPr/>
+        </p:nvPicPr>
+        <p:blipFill>
+          <a:blip r:embed="rId4">
             <a:extLst>
               <a:ext uri="{28A0092B-C50C-407E-A947-70E740481C1C}">
                 <a14:useLocalDpi xmlns:a14="http://schemas.microsoft.com/office/drawing/2010/main" val="0"/>

</xml_diff>

<commit_message>
make export of project reference powerpoint a bit more stable
</commit_message>
<xml_diff>
--- a/src/main/resources/templates/projectreferences/project_template_de.pptx
+++ b/src/main/resources/templates/projectreferences/project_template_de.pptx
@@ -247,7 +247,7 @@
           <a:p>
             <a:fld id="{C3440642-083C-45F1-96AE-6C40D1428CD6}" type="datetimeFigureOut">
               <a:rPr lang="en-GB" smtClean="0"/>
-              <a:t>15/05/2025</a:t>
+              <a:t>24/09/2025</a:t>
             </a:fld>
             <a:endParaRPr lang="en-GB"/>
           </a:p>
@@ -424,7 +424,7 @@
           <a:p>
             <a:fld id="{DEE2F1A5-1147-44AA-941C-401C9E3002E6}" type="datetimeFigureOut">
               <a:rPr lang="en-US" smtClean="0"/>
-              <a:t>5/15/25</a:t>
+              <a:t>9/24/2025</a:t>
             </a:fld>
             <a:endParaRPr lang="en-US"/>
           </a:p>
@@ -2927,8 +2927,8 @@
           <a:lstStyle/>
           <a:p>
             <a:r>
-              <a:rPr lang="de-DE"/>
-              <a:t>Kundensegmentierung ist die Basis für Use Cases, die den Entscheidungsprozess der Kunden positiv unterstützen</a:t>
+              <a:rPr lang="de-DE" dirty="0"/>
+              <a:t>DefaultTitle</a:t>
             </a:r>
           </a:p>
         </p:txBody>
@@ -3075,14 +3075,14 @@
           <a:lstStyle/>
           <a:p>
             <a:r>
-              <a:rPr lang="de-DE"/>
-              <a:t>Die Interaktionen der Verbraucher wurden nicht vollständig über alle Plattformen hinweg erfasst, wodurch wichtige Datenpunkte in der Customer Journey fehlten</a:t>
+              <a:rPr lang="de-DE" dirty="0"/>
+              <a:t>Text1</a:t>
             </a:r>
           </a:p>
           <a:p>
             <a:r>
-              <a:rPr lang="de-DE"/>
-              <a:t>Es bestand die Notwendigkeit, das volle Potenzial der Lifecycle-Daten der Kunden zu nutzen, um Geschäftsstrategien zu entwickeln</a:t>
+              <a:rPr lang="de-DE" dirty="0"/>
+              <a:t>Text2</a:t>
             </a:r>
           </a:p>
         </p:txBody>
@@ -3109,19 +3109,16 @@
           <a:lstStyle/>
           <a:p>
             <a:r>
-              <a:rPr lang="de-DE" err="1"/>
-              <a:t>Predictive</a:t>
+              <a:rPr lang="de-DE" dirty="0"/>
+              <a:t>Text1</a:t>
             </a:r>
+          </a:p>
+          <a:p>
             <a:r>
               <a:rPr lang="de-DE"/>
-              <a:t> Analytics wurde eingesetzt, um die Kundensegmentierung zu verfeinern, wobei die Interaktionshäufigkeit, der Geldwert und die Produktkategorien berücksichtigt wurden</a:t>
+              <a:t>Text2</a:t>
             </a:r>
-          </a:p>
-          <a:p>
-            <a:r>
-              <a:rPr lang="de-DE"/>
-              <a:t>Dies ermöglichte eine präzisere Ausrichtung von Marketingkampagnen, was das Engagement der Verbraucher und ihr Kaufverhalten deutlich verbesserte</a:t>
-            </a:r>
+            <a:endParaRPr lang="de-DE" dirty="0"/>
           </a:p>
         </p:txBody>
       </p:sp>
@@ -3147,22 +3144,14 @@
           <a:lstStyle/>
           <a:p>
             <a:r>
-              <a:rPr lang="de-DE"/>
-              <a:t>Das Hauptziel bestand darin, hochwertige Kunden zu identifizieren und gezielt anzusprechen, um ihre durchschnittliche Bestellmenge zu erhöhen</a:t>
+              <a:rPr lang="de-DE" dirty="0"/>
+              <a:t>Text1</a:t>
             </a:r>
           </a:p>
           <a:p>
             <a:r>
-              <a:rPr lang="de-DE"/>
-              <a:t>Es bestand die Notwendigkeit, die Grenzen der traditionellen Segmentierung zu überwinden, indem ein stärker </a:t>
-            </a:r>
-            <a:r>
-              <a:rPr lang="de-DE" err="1"/>
-              <a:t>Predicitve</a:t>
-            </a:r>
-            <a:r>
-              <a:rPr lang="de-DE"/>
-              <a:t> Analytics-Ansatz gewählt wurde</a:t>
+              <a:rPr lang="de-DE" dirty="0"/>
+              <a:t>Text2</a:t>
             </a:r>
           </a:p>
         </p:txBody>
@@ -3189,8 +3178,8 @@
           <a:lstStyle/>
           <a:p>
             <a:r>
-              <a:rPr lang="de-DE"/>
-              <a:t>Verbessertes Management des Kundenlebens-zyklus durch erweiterte Segmentierung</a:t>
+              <a:rPr lang="de-DE" dirty="0"/>
+              <a:t>Default1</a:t>
             </a:r>
           </a:p>
         </p:txBody>
@@ -3218,8 +3207,9 @@
           <a:p>
             <a:r>
               <a:rPr lang="de-DE"/>
-              <a:t>Verbesserter ROI für Marketingkampagnen durch datengestützte Erkenntnisse</a:t>
+              <a:t>Default3</a:t>
             </a:r>
+            <a:endParaRPr lang="de-DE" dirty="0"/>
           </a:p>
         </p:txBody>
       </p:sp>
@@ -3245,8 +3235,8 @@
           <a:lstStyle/>
           <a:p>
             <a:r>
-              <a:rPr lang="de-DE"/>
-              <a:t>Identifizierung von Kunden mit hohem Wert, was zu größeren Warenkörben führt</a:t>
+              <a:rPr lang="de-DE" dirty="0"/>
+              <a:t>Default2</a:t>
             </a:r>
           </a:p>
         </p:txBody>
@@ -4313,6 +4303,34 @@
 </file>
 
 <file path=customXml/item1.xml><?xml version="1.0" encoding="utf-8"?>
+<p:properties xmlns:p="http://schemas.microsoft.com/office/2006/metadata/properties" xmlns:xsi="http://www.w3.org/2001/XMLSchema-instance" xmlns:pc="http://schemas.microsoft.com/office/infopath/2007/PartnerControls">
+  <documentManagement>
+    <SharedWithUsers xmlns="93dfb1fd-9939-48e8-b7f9-906c8dec5f83">
+      <UserInfo>
+        <DisplayName>Claudia Ciuciu</DisplayName>
+        <AccountId>784</AccountId>
+        <AccountType/>
+      </UserInfo>
+      <UserInfo>
+        <DisplayName>Annie Yim</DisplayName>
+        <AccountId>36</AccountId>
+        <AccountType/>
+      </UserInfo>
+      <UserInfo>
+        <DisplayName>Giuseppe Gagliano</DisplayName>
+        <AccountId>360</AccountId>
+        <AccountType/>
+      </UserInfo>
+    </SharedWithUsers>
+    <lcf76f155ced4ddcb4097134ff3c332f xmlns="3ed6e455-ac74-4dac-a85f-281444f13a89">
+      <Terms xmlns="http://schemas.microsoft.com/office/infopath/2007/PartnerControls"/>
+    </lcf76f155ced4ddcb4097134ff3c332f>
+    <TaxCatchAll xmlns="93dfb1fd-9939-48e8-b7f9-906c8dec5f83" xsi:nil="true"/>
+  </documentManagement>
+</p:properties>
+</file>
+
+<file path=customXml/item2.xml><?xml version="1.0" encoding="utf-8"?>
 <?mso-contentType ?>
 <FormTemplates xmlns="http://schemas.microsoft.com/sharepoint/v3/contenttype/forms">
   <Display>DocumentLibraryForm</Display>
@@ -4321,7 +4339,7 @@
 </FormTemplates>
 </file>
 
-<file path=customXml/item2.xml><?xml version="1.0" encoding="utf-8"?>
+<file path=customXml/item3.xml><?xml version="1.0" encoding="utf-8"?>
 <ct:contentTypeSchema xmlns:ct="http://schemas.microsoft.com/office/2006/metadata/contentType" xmlns:ma="http://schemas.microsoft.com/office/2006/metadata/properties/metaAttributes" ct:_="" ma:_="" ma:contentTypeName="Document" ma:contentTypeID="0x010100C40DA48F075C5B4A97888B7494D83B0A" ma:contentTypeVersion="18" ma:contentTypeDescription="Create a new document." ma:contentTypeScope="" ma:versionID="1a522abe8c59da9d6467652055971ea3">
   <xsd:schema xmlns:xsd="http://www.w3.org/2001/XMLSchema" xmlns:xs="http://www.w3.org/2001/XMLSchema" xmlns:p="http://schemas.microsoft.com/office/2006/metadata/properties" xmlns:ns2="3ed6e455-ac74-4dac-a85f-281444f13a89" xmlns:ns3="93dfb1fd-9939-48e8-b7f9-906c8dec5f83" targetNamespace="http://schemas.microsoft.com/office/2006/metadata/properties" ma:root="true" ma:fieldsID="b19f811aee0631183f61d9d45dafbe9b" ns2:_="" ns3:_="">
     <xsd:import namespace="3ed6e455-ac74-4dac-a85f-281444f13a89"/>
@@ -4576,35 +4594,24 @@
 </ct:contentTypeSchema>
 </file>
 
-<file path=customXml/item3.xml><?xml version="1.0" encoding="utf-8"?>
-<p:properties xmlns:p="http://schemas.microsoft.com/office/2006/metadata/properties" xmlns:xsi="http://www.w3.org/2001/XMLSchema-instance" xmlns:pc="http://schemas.microsoft.com/office/infopath/2007/PartnerControls">
-  <documentManagement>
-    <SharedWithUsers xmlns="93dfb1fd-9939-48e8-b7f9-906c8dec5f83">
-      <UserInfo>
-        <DisplayName>Claudia Ciuciu</DisplayName>
-        <AccountId>784</AccountId>
-        <AccountType/>
-      </UserInfo>
-      <UserInfo>
-        <DisplayName>Annie Yim</DisplayName>
-        <AccountId>36</AccountId>
-        <AccountType/>
-      </UserInfo>
-      <UserInfo>
-        <DisplayName>Giuseppe Gagliano</DisplayName>
-        <AccountId>360</AccountId>
-        <AccountType/>
-      </UserInfo>
-    </SharedWithUsers>
-    <lcf76f155ced4ddcb4097134ff3c332f xmlns="3ed6e455-ac74-4dac-a85f-281444f13a89">
-      <Terms xmlns="http://schemas.microsoft.com/office/infopath/2007/PartnerControls"/>
-    </lcf76f155ced4ddcb4097134ff3c332f>
-    <TaxCatchAll xmlns="93dfb1fd-9939-48e8-b7f9-906c8dec5f83" xsi:nil="true"/>
-  </documentManagement>
-</p:properties>
+<file path=customXml/itemProps1.xml><?xml version="1.0" encoding="utf-8"?>
+<ds:datastoreItem xmlns:ds="http://schemas.openxmlformats.org/officeDocument/2006/customXml" ds:itemID="{E7C53C13-48C7-4544-93BF-9003A9BB3E88}">
+  <ds:schemaRefs>
+    <ds:schemaRef ds:uri="http://www.w3.org/XML/1998/namespace"/>
+    <ds:schemaRef ds:uri="http://purl.org/dc/dcmitype/"/>
+    <ds:schemaRef ds:uri="http://schemas.microsoft.com/office/infopath/2007/PartnerControls"/>
+    <ds:schemaRef ds:uri="http://purl.org/dc/elements/1.1/"/>
+    <ds:schemaRef ds:uri="93dfb1fd-9939-48e8-b7f9-906c8dec5f83"/>
+    <ds:schemaRef ds:uri="http://purl.org/dc/terms/"/>
+    <ds:schemaRef ds:uri="http://schemas.openxmlformats.org/package/2006/metadata/core-properties"/>
+    <ds:schemaRef ds:uri="http://schemas.microsoft.com/office/2006/documentManagement/types"/>
+    <ds:schemaRef ds:uri="3ed6e455-ac74-4dac-a85f-281444f13a89"/>
+    <ds:schemaRef ds:uri="http://schemas.microsoft.com/office/2006/metadata/properties"/>
+  </ds:schemaRefs>
+</ds:datastoreItem>
 </file>
 
-<file path=customXml/itemProps1.xml><?xml version="1.0" encoding="utf-8"?>
+<file path=customXml/itemProps2.xml><?xml version="1.0" encoding="utf-8"?>
 <ds:datastoreItem xmlns:ds="http://schemas.openxmlformats.org/officeDocument/2006/customXml" ds:itemID="{2E225052-F2B8-49FC-A412-5D27ABF2318D}">
   <ds:schemaRefs>
     <ds:schemaRef ds:uri="http://schemas.microsoft.com/sharepoint/v3/contenttype/forms"/>
@@ -4612,7 +4619,7 @@
 </ds:datastoreItem>
 </file>
 
-<file path=customXml/itemProps2.xml><?xml version="1.0" encoding="utf-8"?>
+<file path=customXml/itemProps3.xml><?xml version="1.0" encoding="utf-8"?>
 <ds:datastoreItem xmlns:ds="http://schemas.openxmlformats.org/officeDocument/2006/customXml" ds:itemID="{A364AE00-00DD-413F-A79B-723585B863D8}">
   <ds:schemaRefs>
     <ds:schemaRef ds:uri="3ed6e455-ac74-4dac-a85f-281444f13a89"/>
@@ -4631,23 +4638,6 @@
 </ds:datastoreItem>
 </file>
 
-<file path=customXml/itemProps3.xml><?xml version="1.0" encoding="utf-8"?>
-<ds:datastoreItem xmlns:ds="http://schemas.openxmlformats.org/officeDocument/2006/customXml" ds:itemID="{E7C53C13-48C7-4544-93BF-9003A9BB3E88}">
-  <ds:schemaRefs>
-    <ds:schemaRef ds:uri="http://www.w3.org/XML/1998/namespace"/>
-    <ds:schemaRef ds:uri="http://purl.org/dc/dcmitype/"/>
-    <ds:schemaRef ds:uri="http://schemas.microsoft.com/office/infopath/2007/PartnerControls"/>
-    <ds:schemaRef ds:uri="http://purl.org/dc/elements/1.1/"/>
-    <ds:schemaRef ds:uri="93dfb1fd-9939-48e8-b7f9-906c8dec5f83"/>
-    <ds:schemaRef ds:uri="http://purl.org/dc/terms/"/>
-    <ds:schemaRef ds:uri="http://schemas.openxmlformats.org/package/2006/metadata/core-properties"/>
-    <ds:schemaRef ds:uri="http://schemas.microsoft.com/office/2006/documentManagement/types"/>
-    <ds:schemaRef ds:uri="3ed6e455-ac74-4dac-a85f-281444f13a89"/>
-    <ds:schemaRef ds:uri="http://schemas.microsoft.com/office/2006/metadata/properties"/>
-  </ds:schemaRefs>
-</ds:datastoreItem>
-</file>
-
 <file path=docMetadata/LabelInfo.xml><?xml version="1.0" encoding="utf-8"?>
 <clbl:labelList xmlns:clbl="http://schemas.microsoft.com/office/2020/mipLabelMetadata">
   <clbl:label id="{b00367e2-193a-4f48-94de-7245d45c0947}" enabled="0" method="" siteId="{b00367e2-193a-4f48-94de-7245d45c0947}" removed="1"/>

</xml_diff>